<commit_message>
Deck Tirabasso v2: slide Natali Bolgar dal video del colonnato
La slide usa ora la miniatura e due fotogrammi del film giusto. In tutto
il deck: niente primi piani al volto, i dettagli ravvicinati sono solo
sul cappello.

Co-Authored-By: Claude Opus 5.5 <noreply@anthropic.com>
Claude-Session: https://claude.ai/code/session_019CimPMJNPswxhYiugHUDKX
</commit_message>
<xml_diff>
--- a/tirabasso/campagna-fw26-27/Tirabasso_Un_hiver_a_Paris_v2.pptx
+++ b/tirabasso/campagna-fw26-27/Tirabasso_Un_hiver_a_Paris_v2.pptx
@@ -692,7 +692,7 @@
           <a:p>
             <a:r>
               <a:rPr lang="en-US" dirty="0"/>
-              <a:t>Screenshot del post @natalibolgar.</a:t>
+              <a:t>Miniatura e fotogrammi dal video @natalibolgar scaricato nella cartella (SaveClip). Il video si apre a parte durante la presentazione.</a:t>
             </a:r>
             <a:endParaRPr lang="en-US" dirty="0"/>
           </a:p>
@@ -2858,7 +2858,7 @@
       </p:grpSpPr>
       <p:pic>
         <p:nvPicPr>
-          <p:cNvPr id="2" name="Image 0" descr="img/bolgar.jpg">    </p:cNvPr>
+          <p:cNvPr id="2" name="Image 0" descr="img/nb_thumb.jpg">    </p:cNvPr>
           <p:cNvPicPr>
             <a:picLocks noChangeAspect="1"/>
           </p:cNvPicPr>
@@ -2866,28 +2866,74 @@
         </p:nvPicPr>
         <p:blipFill>
           <a:blip r:embed="rId1"/>
-          <a:srcRect l="6677" r="6677" t="0" b="0"/>
+          <a:srcRect l="5074" r="5074" t="0" b="0"/>
           <a:stretch/>
         </p:blipFill>
         <p:spPr>
           <a:xfrm>
             <a:off x="0" y="0"/>
-            <a:ext cx="5669280" cy="6858000"/>
+            <a:ext cx="3474720" cy="6858000"/>
           </a:xfrm>
           <a:prstGeom prst="rect">
             <a:avLst/>
           </a:prstGeom>
         </p:spPr>
       </p:pic>
-      <p:sp>
-        <p:nvSpPr>
-          <p:cNvPr id="3" name="Text 0"/>
-          <p:cNvSpPr txBox="1"/>
-          <p:nvPr/>
-        </p:nvSpPr>
-        <p:spPr>
-          <a:xfrm>
-            <a:off x="6309360" y="731520"/>
+      <p:pic>
+        <p:nvPicPr>
+          <p:cNvPr id="3" name="Image 1" descr="img/nb_5.3.jpg">    </p:cNvPr>
+          <p:cNvPicPr>
+            <a:picLocks noChangeAspect="1"/>
+          </p:cNvPicPr>
+          <p:nvPr/>
+        </p:nvPicPr>
+        <p:blipFill>
+          <a:blip r:embed="rId2"/>
+          <a:srcRect l="0" r="0" t="4755" b="4755"/>
+          <a:stretch/>
+        </p:blipFill>
+        <p:spPr>
+          <a:xfrm>
+            <a:off x="3566160" y="0"/>
+            <a:ext cx="2103120" cy="3383280"/>
+          </a:xfrm>
+          <a:prstGeom prst="rect">
+            <a:avLst/>
+          </a:prstGeom>
+        </p:spPr>
+      </p:pic>
+      <p:pic>
+        <p:nvPicPr>
+          <p:cNvPr id="4" name="Image 2" descr="img/nb_11.5.jpg">    </p:cNvPr>
+          <p:cNvPicPr>
+            <a:picLocks noChangeAspect="1"/>
+          </p:cNvPicPr>
+          <p:nvPr/>
+        </p:nvPicPr>
+        <p:blipFill>
+          <a:blip r:embed="rId3"/>
+          <a:srcRect l="0" r="0" t="4280" b="5231"/>
+          <a:stretch/>
+        </p:blipFill>
+        <p:spPr>
+          <a:xfrm>
+            <a:off x="3566160" y="3474720"/>
+            <a:ext cx="2103120" cy="3383280"/>
+          </a:xfrm>
+          <a:prstGeom prst="rect">
+            <a:avLst/>
+          </a:prstGeom>
+        </p:spPr>
+      </p:pic>
+      <p:sp>
+        <p:nvSpPr>
+          <p:cNvPr id="5" name="Text 0"/>
+          <p:cNvSpPr txBox="1"/>
+          <p:nvPr/>
+        </p:nvSpPr>
+        <p:spPr>
+          <a:xfrm>
+            <a:off x="6309360" y="548640"/>
             <a:ext cx="5486400" cy="274320"/>
           </a:xfrm>
           <a:prstGeom prst="rect">
@@ -2920,13 +2966,13 @@
       </p:sp>
       <p:sp>
         <p:nvSpPr>
-          <p:cNvPr id="4" name="Text 1"/>
-          <p:cNvSpPr txBox="1"/>
-          <p:nvPr/>
-        </p:nvSpPr>
-        <p:spPr>
-          <a:xfrm>
-            <a:off x="6309360" y="1097280"/>
+          <p:cNvPr id="6" name="Text 1"/>
+          <p:cNvSpPr txBox="1"/>
+          <p:nvPr/>
+        </p:nvSpPr>
+        <p:spPr>
+          <a:xfrm>
+            <a:off x="6309360" y="868680"/>
             <a:ext cx="5242255" cy="731520"/>
           </a:xfrm>
           <a:prstGeom prst="rect">
@@ -2959,13 +3005,13 @@
       </p:sp>
       <p:sp>
         <p:nvSpPr>
-          <p:cNvPr id="5" name="Text 2"/>
-          <p:cNvSpPr txBox="1"/>
-          <p:nvPr/>
-        </p:nvSpPr>
-        <p:spPr>
-          <a:xfrm>
-            <a:off x="6309360" y="1828800"/>
+          <p:cNvPr id="7" name="Text 2"/>
+          <p:cNvSpPr txBox="1"/>
+          <p:nvPr/>
+        </p:nvSpPr>
+        <p:spPr>
+          <a:xfrm>
+            <a:off x="6309360" y="1554480"/>
             <a:ext cx="5242255" cy="365760"/>
           </a:xfrm>
           <a:prstGeom prst="rect">
@@ -2996,7 +3042,7 @@
                 <a:ea typeface="Arial" pitchFamily="34" charset="-122"/>
                 <a:cs typeface="Arial" pitchFamily="34" charset="-120"/>
               </a:rPr>
-              <a:t>Limited edition, Instagram</a:t>
+              <a:t>Film Instagram, dal colonnato alla città</a:t>
             </a:r>
             <a:endParaRPr lang="en-US" sz="1300" dirty="0"/>
           </a:p>
@@ -3004,13 +3050,13 @@
       </p:sp>
       <p:sp>
         <p:nvSpPr>
-          <p:cNvPr id="6" name="Text 3"/>
-          <p:cNvSpPr txBox="1"/>
-          <p:nvPr/>
-        </p:nvSpPr>
-        <p:spPr>
-          <a:xfrm>
-            <a:off x="6309360" y="2514600"/>
+          <p:cNvPr id="8" name="Text 3"/>
+          <p:cNvSpPr txBox="1"/>
+          <p:nvPr/>
+        </p:nvSpPr>
+        <p:spPr>
+          <a:xfrm>
+            <a:off x="6309360" y="2103120"/>
             <a:ext cx="5486400" cy="274320"/>
           </a:xfrm>
           <a:prstGeom prst="rect">
@@ -3043,14 +3089,14 @@
       </p:sp>
       <p:sp>
         <p:nvSpPr>
-          <p:cNvPr id="7" name="Text 4"/>
-          <p:cNvSpPr txBox="1"/>
-          <p:nvPr/>
-        </p:nvSpPr>
-        <p:spPr>
-          <a:xfrm>
-            <a:off x="6309360" y="2834640"/>
-            <a:ext cx="5242255" cy="1280160"/>
+          <p:cNvPr id="9" name="Text 4"/>
+          <p:cNvSpPr txBox="1"/>
+          <p:nvPr/>
+        </p:nvSpPr>
+        <p:spPr>
+          <a:xfrm>
+            <a:off x="6309360" y="2395728"/>
+            <a:ext cx="5242255" cy="914400"/>
           </a:xfrm>
           <a:prstGeom prst="rect">
             <a:avLst/>
@@ -3072,7 +3118,7 @@
               <a:buNone/>
             </a:pPr>
             <a:r>
-              <a:rPr lang="en-US" sz="1350" dirty="0">
+              <a:rPr lang="en-US" sz="1250" dirty="0">
                 <a:solidFill>
                   <a:srgbClr val="DCDDDC"/>
                 </a:solidFill>
@@ -3080,21 +3126,21 @@
                 <a:ea typeface="Arial" pitchFamily="34" charset="-122"/>
                 <a:cs typeface="Arial" pitchFamily="34" charset="-120"/>
               </a:rPr>
-              <a:t>Un primo piano fuori fuoco, lento, da cui emerge solo l’oro degli orecchini.</a:t>
-            </a:r>
-            <a:endParaRPr lang="en-US" sz="1350" dirty="0"/>
-          </a:p>
-        </p:txBody>
-      </p:sp>
-      <p:sp>
-        <p:nvSpPr>
-          <p:cNvPr id="8" name="Text 5"/>
-          <p:cNvSpPr txBox="1"/>
-          <p:nvPr/>
-        </p:nvSpPr>
-        <p:spPr>
-          <a:xfrm>
-            <a:off x="6309360" y="4206240"/>
+              <a:t>Si apre con lei che passa di corsa tra le colonne. Poi la città usata come architettura: strisce viste dall’alto, scale, un ascensore.</a:t>
+            </a:r>
+            <a:endParaRPr lang="en-US" sz="1250" dirty="0"/>
+          </a:p>
+        </p:txBody>
+      </p:sp>
+      <p:sp>
+        <p:nvSpPr>
+          <p:cNvPr id="10" name="Text 5"/>
+          <p:cNvSpPr txBox="1"/>
+          <p:nvPr/>
+        </p:nvSpPr>
+        <p:spPr>
+          <a:xfrm>
+            <a:off x="6309360" y="3429000"/>
             <a:ext cx="5486400" cy="274320"/>
           </a:xfrm>
           <a:prstGeom prst="rect">
@@ -3127,14 +3173,14 @@
       </p:sp>
       <p:sp>
         <p:nvSpPr>
-          <p:cNvPr id="9" name="Text 6"/>
-          <p:cNvSpPr txBox="1"/>
-          <p:nvPr/>
-        </p:nvSpPr>
-        <p:spPr>
-          <a:xfrm>
-            <a:off x="6309360" y="4526280"/>
-            <a:ext cx="5242255" cy="1828800"/>
+          <p:cNvPr id="11" name="Text 6"/>
+          <p:cNvSpPr txBox="1"/>
+          <p:nvPr/>
+        </p:nvSpPr>
+        <p:spPr>
+          <a:xfrm>
+            <a:off x="6309360" y="3721608"/>
+            <a:ext cx="5242255" cy="1188720"/>
           </a:xfrm>
           <a:prstGeom prst="rect">
             <a:avLst/>
@@ -3148,13 +3194,13 @@
           <a:p>
             <a:pPr marL="177800" indent="-177800">
               <a:spcAft>
-                <a:spcPts val="600"/>
+                <a:spcPts val="500"/>
               </a:spcAft>
               <a:buSzPct val="100000"/>
               <a:buChar char="•"/>
             </a:pPr>
             <a:r>
-              <a:rPr lang="en-US" sz="1350" dirty="0">
+              <a:rPr lang="en-US" sz="1250" dirty="0">
                 <a:solidFill>
                   <a:srgbClr val="FFFFFF"/>
                 </a:solidFill>
@@ -3162,20 +3208,20 @@
                 <a:ea typeface="Arial" pitchFamily="34" charset="-122"/>
                 <a:cs typeface="Arial" pitchFamily="34" charset="-120"/>
               </a:rPr>
-              <a:t>I dettagli ravvicinati e sfocati come pause tra le scene</a:t>
-            </a:r>
-            <a:endParaRPr lang="en-US" sz="1350" dirty="0"/>
+              <a:t>La scena iniziale: lei che attraversa un colonnato</a:t>
+            </a:r>
+            <a:endParaRPr lang="en-US" sz="1250" dirty="0"/>
           </a:p>
           <a:p>
             <a:pPr marL="177800" indent="-177800">
               <a:spcAft>
-                <a:spcPts val="600"/>
+                <a:spcPts val="500"/>
               </a:spcAft>
               <a:buSzPct val="100000"/>
               <a:buChar char="•"/>
             </a:pPr>
             <a:r>
-              <a:rPr lang="en-US" sz="1350" dirty="0">
+              <a:rPr lang="en-US" sz="1250" dirty="0">
                 <a:solidFill>
                   <a:srgbClr val="FFFFFF"/>
                 </a:solidFill>
@@ -3183,20 +3229,20 @@
                 <a:ea typeface="Arial" pitchFamily="34" charset="-122"/>
                 <a:cs typeface="Arial" pitchFamily="34" charset="-120"/>
               </a:rPr>
-              <a:t>L’oro caldo come unico accento sulla palette grigia</a:t>
-            </a:r>
-            <a:endParaRPr lang="en-US" sz="1350" dirty="0"/>
+              <a:t>La città come geometria: dall’alto, le scale, l’ascensore</a:t>
+            </a:r>
+            <a:endParaRPr lang="en-US" sz="1250" dirty="0"/>
           </a:p>
           <a:p>
             <a:pPr marL="177800" indent="-177800">
               <a:spcAft>
-                <a:spcPts val="600"/>
+                <a:spcPts val="500"/>
               </a:spcAft>
               <a:buSzPct val="100000"/>
               <a:buChar char="•"/>
             </a:pPr>
             <a:r>
-              <a:rPr lang="en-US" sz="1350" dirty="0">
+              <a:rPr lang="en-US" sz="1250" dirty="0">
                 <a:solidFill>
                   <a:srgbClr val="FFFFFF"/>
                 </a:solidFill>
@@ -3204,15 +3250,118 @@
                 <a:ea typeface="Arial" pitchFamily="34" charset="-122"/>
                 <a:cs typeface="Arial" pitchFamily="34" charset="-120"/>
               </a:rPr>
-              <a:t>Un ritmo lento per il film</a:t>
-            </a:r>
-            <a:endParaRPr lang="en-US" sz="1350" dirty="0"/>
-          </a:p>
-        </p:txBody>
-      </p:sp>
-      <p:sp>
-        <p:nvSpPr>
-          <p:cNvPr id="10" name="Text 7"/>
+              <a:t>La figura intera, piccola dentro l’architettura</a:t>
+            </a:r>
+            <a:endParaRPr lang="en-US" sz="1250" dirty="0"/>
+          </a:p>
+        </p:txBody>
+      </p:sp>
+      <p:sp>
+        <p:nvSpPr>
+          <p:cNvPr id="12" name="Text 7"/>
+          <p:cNvSpPr txBox="1"/>
+          <p:nvPr/>
+        </p:nvSpPr>
+        <p:spPr>
+          <a:xfrm>
+            <a:off x="6309360" y="5029200"/>
+            <a:ext cx="5486400" cy="274320"/>
+          </a:xfrm>
+          <a:prstGeom prst="rect">
+            <a:avLst/>
+          </a:prstGeom>
+          <a:noFill/>
+          <a:ln/>
+        </p:spPr>
+        <p:txBody>
+          <a:bodyPr wrap="square" lIns="0" tIns="0" rIns="0" bIns="0" rtlCol="0" anchor="ctr"/>
+          <a:lstStyle/>
+          <a:p>
+            <a:pPr indent="0" marL="0">
+              <a:buNone/>
+            </a:pPr>
+            <a:r>
+              <a:rPr lang="en-US" sz="1000" spc="400" kern="0" dirty="0">
+                <a:solidFill>
+                  <a:srgbClr val="A8875A"/>
+                </a:solidFill>
+                <a:latin typeface="Arial" pitchFamily="34" charset="0"/>
+                <a:ea typeface="Arial" pitchFamily="34" charset="-122"/>
+                <a:cs typeface="Arial" pitchFamily="34" charset="-120"/>
+              </a:rPr>
+              <a:t>COSA LASCIAMO</a:t>
+            </a:r>
+            <a:endParaRPr lang="en-US" sz="1000" dirty="0"/>
+          </a:p>
+        </p:txBody>
+      </p:sp>
+      <p:sp>
+        <p:nvSpPr>
+          <p:cNvPr id="13" name="Text 8"/>
+          <p:cNvSpPr txBox="1"/>
+          <p:nvPr/>
+        </p:nvSpPr>
+        <p:spPr>
+          <a:xfrm>
+            <a:off x="6309360" y="5321808"/>
+            <a:ext cx="5242255" cy="1188720"/>
+          </a:xfrm>
+          <a:prstGeom prst="rect">
+            <a:avLst/>
+          </a:prstGeom>
+          <a:noFill/>
+          <a:ln/>
+        </p:spPr>
+        <p:txBody>
+          <a:bodyPr wrap="square" lIns="0" tIns="0" rIns="0" bIns="0" rtlCol="0" anchor="t"/>
+          <a:lstStyle/>
+          <a:p>
+            <a:pPr marL="177800" indent="-177800">
+              <a:spcAft>
+                <a:spcPts val="500"/>
+              </a:spcAft>
+              <a:buSzPct val="100000"/>
+              <a:buChar char="•"/>
+            </a:pPr>
+            <a:r>
+              <a:rPr lang="en-US" sz="1250" dirty="0">
+                <a:solidFill>
+                  <a:srgbClr val="A9ACAE"/>
+                </a:solidFill>
+                <a:latin typeface="Arial" pitchFamily="34" charset="0"/>
+                <a:ea typeface="Arial" pitchFamily="34" charset="-122"/>
+                <a:cs typeface="Arial" pitchFamily="34" charset="-120"/>
+              </a:rPr>
+              <a:t>Il ritmo veloce e il tono troppo smart: il nostro è più lento e romantico</a:t>
+            </a:r>
+            <a:endParaRPr lang="en-US" sz="1250" dirty="0"/>
+          </a:p>
+          <a:p>
+            <a:pPr marL="177800" indent="-177800">
+              <a:spcAft>
+                <a:spcPts val="500"/>
+              </a:spcAft>
+              <a:buSzPct val="100000"/>
+              <a:buChar char="•"/>
+            </a:pPr>
+            <a:r>
+              <a:rPr lang="en-US" sz="1250" dirty="0">
+                <a:solidFill>
+                  <a:srgbClr val="A9ACAE"/>
+                </a:solidFill>
+                <a:latin typeface="Arial" pitchFamily="34" charset="0"/>
+                <a:ea typeface="Arial" pitchFamily="34" charset="-122"/>
+                <a:cs typeface="Arial" pitchFamily="34" charset="-120"/>
+              </a:rPr>
+              <a:t>I primi piani al volto: da vicino riprendiamo solo il cappello</a:t>
+            </a:r>
+            <a:endParaRPr lang="en-US" sz="1250" dirty="0"/>
+          </a:p>
+        </p:txBody>
+      </p:sp>
+      <p:sp>
+        <p:nvSpPr>
+          <p:cNvPr id="14" name="Text 9"/>
           <p:cNvSpPr txBox="1"/>
           <p:nvPr/>
         </p:nvSpPr>
@@ -4241,7 +4390,7 @@
                 <a:ea typeface="Arial" pitchFamily="34" charset="-122"/>
                 <a:cs typeface="Arial" pitchFamily="34" charset="-120"/>
               </a:rPr>
-              <a:t>La pioggia la ferma sotto un portico. Un momento vicino al viso e al cappello.</a:t>
+              <a:t>La pioggia la ferma sotto un portico. Un dettaglio stretto sul cappello, la pioggia sulla tesa.</a:t>
             </a:r>
             <a:endParaRPr lang="en-US" sz="1150" dirty="0"/>
           </a:p>
@@ -7696,7 +7845,7 @@
         </p:nvSpPr>
         <p:spPr>
           <a:xfrm>
-            <a:off x="685800" y="2103120"/>
+            <a:off x="685800" y="2011680"/>
             <a:ext cx="548640" cy="365760"/>
           </a:xfrm>
           <a:prstGeom prst="rect">
@@ -7735,7 +7884,7 @@
         </p:nvSpPr>
         <p:spPr>
           <a:xfrm>
-            <a:off x="1325880" y="2103120"/>
+            <a:off x="1325880" y="2011680"/>
             <a:ext cx="5852160" cy="320040"/>
           </a:xfrm>
           <a:prstGeom prst="rect">
@@ -7774,7 +7923,7 @@
         </p:nvSpPr>
         <p:spPr>
           <a:xfrm>
-            <a:off x="1325880" y="2432304"/>
+            <a:off x="1325880" y="2340864"/>
             <a:ext cx="5852160" cy="457200"/>
           </a:xfrm>
           <a:prstGeom prst="rect">
@@ -7819,7 +7968,7 @@
         </p:nvSpPr>
         <p:spPr>
           <a:xfrm>
-            <a:off x="685800" y="2971800"/>
+            <a:off x="685800" y="2743200"/>
             <a:ext cx="548640" cy="365760"/>
           </a:xfrm>
           <a:prstGeom prst="rect">
@@ -7858,7 +8007,7 @@
         </p:nvSpPr>
         <p:spPr>
           <a:xfrm>
-            <a:off x="1325880" y="2971800"/>
+            <a:off x="1325880" y="2743200"/>
             <a:ext cx="5852160" cy="320040"/>
           </a:xfrm>
           <a:prstGeom prst="rect">
@@ -7897,7 +8046,7 @@
         </p:nvSpPr>
         <p:spPr>
           <a:xfrm>
-            <a:off x="1325880" y="3300984"/>
+            <a:off x="1325880" y="3072384"/>
             <a:ext cx="5852160" cy="457200"/>
           </a:xfrm>
           <a:prstGeom prst="rect">
@@ -7942,7 +8091,7 @@
         </p:nvSpPr>
         <p:spPr>
           <a:xfrm>
-            <a:off x="685800" y="3840480"/>
+            <a:off x="685800" y="3474720"/>
             <a:ext cx="548640" cy="365760"/>
           </a:xfrm>
           <a:prstGeom prst="rect">
@@ -7981,7 +8130,7 @@
         </p:nvSpPr>
         <p:spPr>
           <a:xfrm>
-            <a:off x="1325880" y="3840480"/>
+            <a:off x="1325880" y="3474720"/>
             <a:ext cx="5852160" cy="320040"/>
           </a:xfrm>
           <a:prstGeom prst="rect">
@@ -8020,7 +8169,7 @@
         </p:nvSpPr>
         <p:spPr>
           <a:xfrm>
-            <a:off x="1325880" y="4169664"/>
+            <a:off x="1325880" y="3803904"/>
             <a:ext cx="5852160" cy="457200"/>
           </a:xfrm>
           <a:prstGeom prst="rect">
@@ -8065,7 +8214,7 @@
         </p:nvSpPr>
         <p:spPr>
           <a:xfrm>
-            <a:off x="685800" y="4709160"/>
+            <a:off x="685800" y="4206240"/>
             <a:ext cx="548640" cy="365760"/>
           </a:xfrm>
           <a:prstGeom prst="rect">
@@ -8104,7 +8253,7 @@
         </p:nvSpPr>
         <p:spPr>
           <a:xfrm>
-            <a:off x="1325880" y="4709160"/>
+            <a:off x="1325880" y="4206240"/>
             <a:ext cx="5852160" cy="320040"/>
           </a:xfrm>
           <a:prstGeom prst="rect">
@@ -8143,7 +8292,7 @@
         </p:nvSpPr>
         <p:spPr>
           <a:xfrm>
-            <a:off x="1325880" y="5038344"/>
+            <a:off x="1325880" y="4535424"/>
             <a:ext cx="5852160" cy="457200"/>
           </a:xfrm>
           <a:prstGeom prst="rect">
@@ -8188,7 +8337,7 @@
         </p:nvSpPr>
         <p:spPr>
           <a:xfrm>
-            <a:off x="685800" y="5577840"/>
+            <a:off x="685800" y="4937760"/>
             <a:ext cx="548640" cy="365760"/>
           </a:xfrm>
           <a:prstGeom prst="rect">
@@ -8227,7 +8376,7 @@
         </p:nvSpPr>
         <p:spPr>
           <a:xfrm>
-            <a:off x="1325880" y="5577840"/>
+            <a:off x="1325880" y="4937760"/>
             <a:ext cx="5852160" cy="320040"/>
           </a:xfrm>
           <a:prstGeom prst="rect">
@@ -8266,7 +8415,7 @@
         </p:nvSpPr>
         <p:spPr>
           <a:xfrm>
-            <a:off x="1325880" y="5907024"/>
+            <a:off x="1325880" y="5266944"/>
             <a:ext cx="5852160" cy="457200"/>
           </a:xfrm>
           <a:prstGeom prst="rect">
@@ -8306,6 +8455,129 @@
       <p:sp>
         <p:nvSpPr>
           <p:cNvPr id="20" name="Text 17"/>
+          <p:cNvSpPr txBox="1"/>
+          <p:nvPr/>
+        </p:nvSpPr>
+        <p:spPr>
+          <a:xfrm>
+            <a:off x="685800" y="5669280"/>
+            <a:ext cx="548640" cy="365760"/>
+          </a:xfrm>
+          <a:prstGeom prst="rect">
+            <a:avLst/>
+          </a:prstGeom>
+          <a:noFill/>
+          <a:ln/>
+        </p:spPr>
+        <p:txBody>
+          <a:bodyPr wrap="square" lIns="0" tIns="0" rIns="0" bIns="0" rtlCol="0" anchor="ctr"/>
+          <a:lstStyle/>
+          <a:p>
+            <a:pPr indent="0" marL="0">
+              <a:buNone/>
+            </a:pPr>
+            <a:r>
+              <a:rPr lang="en-US" sz="1800" i="1" dirty="0">
+                <a:solidFill>
+                  <a:srgbClr val="A8875A"/>
+                </a:solidFill>
+                <a:latin typeface="Cambria" pitchFamily="34" charset="0"/>
+                <a:ea typeface="Cambria" pitchFamily="34" charset="-122"/>
+                <a:cs typeface="Cambria" pitchFamily="34" charset="-120"/>
+              </a:rPr>
+              <a:t>06</a:t>
+            </a:r>
+            <a:endParaRPr lang="en-US" sz="1800" dirty="0"/>
+          </a:p>
+        </p:txBody>
+      </p:sp>
+      <p:sp>
+        <p:nvSpPr>
+          <p:cNvPr id="21" name="Text 18"/>
+          <p:cNvSpPr txBox="1"/>
+          <p:nvPr/>
+        </p:nvSpPr>
+        <p:spPr>
+          <a:xfrm>
+            <a:off x="1325880" y="5669280"/>
+            <a:ext cx="5852160" cy="320040"/>
+          </a:xfrm>
+          <a:prstGeom prst="rect">
+            <a:avLst/>
+          </a:prstGeom>
+          <a:noFill/>
+          <a:ln/>
+        </p:spPr>
+        <p:txBody>
+          <a:bodyPr wrap="square" lIns="0" tIns="0" rIns="0" bIns="0" rtlCol="0" anchor="ctr"/>
+          <a:lstStyle/>
+          <a:p>
+            <a:pPr indent="0" marL="0">
+              <a:buNone/>
+            </a:pPr>
+            <a:r>
+              <a:rPr lang="en-US" sz="1400" b="1" dirty="0">
+                <a:solidFill>
+                  <a:srgbClr val="1E2023"/>
+                </a:solidFill>
+                <a:latin typeface="Arial" pitchFamily="34" charset="0"/>
+                <a:ea typeface="Arial" pitchFamily="34" charset="-122"/>
+                <a:cs typeface="Arial" pitchFamily="34" charset="-120"/>
+              </a:rPr>
+              <a:t>Niente primi piani al volto</a:t>
+            </a:r>
+            <a:endParaRPr lang="en-US" sz="1400" dirty="0"/>
+          </a:p>
+        </p:txBody>
+      </p:sp>
+      <p:sp>
+        <p:nvSpPr>
+          <p:cNvPr id="22" name="Text 19"/>
+          <p:cNvSpPr txBox="1"/>
+          <p:nvPr/>
+        </p:nvSpPr>
+        <p:spPr>
+          <a:xfrm>
+            <a:off x="1325880" y="5998464"/>
+            <a:ext cx="5852160" cy="457200"/>
+          </a:xfrm>
+          <a:prstGeom prst="rect">
+            <a:avLst/>
+          </a:prstGeom>
+          <a:noFill/>
+          <a:ln/>
+        </p:spPr>
+        <p:txBody>
+          <a:bodyPr wrap="square" lIns="0" tIns="0" rIns="0" bIns="0" rtlCol="0" anchor="t"/>
+          <a:lstStyle/>
+          <a:p>
+            <a:pPr indent="0" marL="0">
+              <a:lnSpc>
+                <a:spcPct val="115000"/>
+              </a:lnSpc>
+              <a:spcAft>
+                <a:spcPts val="600"/>
+              </a:spcAft>
+              <a:buNone/>
+            </a:pPr>
+            <a:r>
+              <a:rPr lang="en-US" sz="1200" dirty="0">
+                <a:solidFill>
+                  <a:srgbClr val="5E6266"/>
+                </a:solidFill>
+                <a:latin typeface="Arial" pitchFamily="34" charset="0"/>
+                <a:ea typeface="Arial" pitchFamily="34" charset="-122"/>
+                <a:cs typeface="Arial" pitchFamily="34" charset="-120"/>
+              </a:rPr>
+              <a:t>Lo spazio è per la figura intera. Da vicino riprendiamo solo il cappello.</a:t>
+            </a:r>
+            <a:endParaRPr lang="en-US" sz="1200" dirty="0"/>
+          </a:p>
+        </p:txBody>
+      </p:sp>
+      <p:sp>
+        <p:nvSpPr>
+          <p:cNvPr id="23" name="Text 20"/>
           <p:cNvSpPr txBox="1"/>
           <p:nvPr/>
         </p:nvSpPr>
@@ -8989,7 +9261,7 @@
         <p:spPr>
           <a:xfrm>
             <a:off x="6583680" y="1143000"/>
-            <a:ext cx="4937760" cy="1188720"/>
+            <a:ext cx="4937760" cy="1280160"/>
           </a:xfrm>
           <a:prstGeom prst="rect">
             <a:avLst/>
@@ -9011,7 +9283,7 @@
               <a:buNone/>
             </a:pPr>
             <a:r>
-              <a:rPr lang="en-US" sz="1400" dirty="0">
+              <a:rPr lang="en-US" sz="1300" dirty="0">
                 <a:solidFill>
                   <a:srgbClr val="DCDDDC"/>
                 </a:solidFill>
@@ -9019,9 +9291,9 @@
                 <a:ea typeface="Arial" pitchFamily="34" charset="-122"/>
                 <a:cs typeface="Arial" pitchFamily="34" charset="-120"/>
               </a:rPr>
-              <a:t>In ogni scena il cappello definisce la silhouette. Alterniamo figura intera e dettagli ravvicinati per rendere leggibili forma, feltro e finiture anche mentre lei cammina. L’unico colore acceso concesso è il suo.</a:t>
-            </a:r>
-            <a:endParaRPr lang="en-US" sz="1400" dirty="0"/>
+              <a:t>In ogni scena il cappello definisce la silhouette. Alterniamo la figura intera ai dettagli del cappello (feltro, nastro, tesa bagnata) per renderlo leggibile anche mentre lei cammina. Niente primi piani al volto. L’unico colore acceso concesso è il suo.</a:t>
+            </a:r>
+            <a:endParaRPr lang="en-US" sz="1300" dirty="0"/>
           </a:p>
         </p:txBody>
       </p:sp>

</xml_diff>

<commit_message>
Deck Tirabasso v2: foto prodotto su sfondo bianco nella slide del cappello
Le cinque foto dalla cartella Drive sono scontornate e rimesse su bianco
pulito, con un'ombra morbida. Sostituiscono i modelli di catalogo usati
come esempio. Le foto ripulite sono salvate anche a parte.

Co-Authored-By: Claude Opus 5.5 <noreply@anthropic.com>
Claude-Session: https://claude.ai/code/session_019CimPMJNPswxhYiugHUDKX
</commit_message>
<xml_diff>
--- a/tirabasso/campagna-fw26-27/Tirabasso_Un_hiver_a_Paris_v2.pptx
+++ b/tirabasso/campagna-fw26-27/Tirabasso_Un_hiver_a_Paris_v2.pptx
@@ -9299,7 +9299,7 @@
       </p:sp>
       <p:pic>
         <p:nvPicPr>
-          <p:cNvPr id="5" name="Image 0" descr="img/hat1.jpg">    </p:cNvPr>
+          <p:cNvPr id="5" name="Image 0" descr="img/prod0.jpg">    </p:cNvPr>
           <p:cNvPicPr>
             <a:picLocks noChangeAspect="1"/>
           </p:cNvPicPr>
@@ -9307,13 +9307,13 @@
         </p:nvPicPr>
         <p:blipFill>
           <a:blip r:embed="rId1"/>
-          <a:srcRect l="0" r="0" t="10714" b="10714"/>
+          <a:srcRect l="0" r="0" t="51" b="41"/>
           <a:stretch/>
         </p:blipFill>
         <p:spPr>
           <a:xfrm>
-            <a:off x="685800" y="2606040"/>
-            <a:ext cx="2560320" cy="3017520"/>
+            <a:off x="685800" y="2697480"/>
+            <a:ext cx="1984248" cy="2478024"/>
           </a:xfrm>
           <a:prstGeom prst="rect">
             <a:avLst/>
@@ -9328,8 +9328,8 @@
         </p:nvSpPr>
         <p:spPr>
           <a:xfrm>
-            <a:off x="685800" y="5760720"/>
-            <a:ext cx="2560320" cy="320040"/>
+            <a:off x="685800" y="5303520"/>
+            <a:ext cx="1984248" cy="457200"/>
           </a:xfrm>
           <a:prstGeom prst="rect">
             <a:avLst/>
@@ -9351,7 +9351,7 @@
               <a:buNone/>
             </a:pPr>
             <a:r>
-              <a:rPr lang="en-US" sz="1200" dirty="0">
+              <a:rPr lang="en-US" sz="1150" dirty="0">
                 <a:solidFill>
                   <a:srgbClr val="DCDDDC"/>
                 </a:solidFill>
@@ -9359,15 +9359,15 @@
                 <a:ea typeface="Arial" pitchFamily="34" charset="-122"/>
                 <a:cs typeface="Arial" pitchFamily="34" charset="-120"/>
               </a:rPr>
-              <a:t>Fedora in feltro cammello</a:t>
-            </a:r>
-            <a:endParaRPr lang="en-US" sz="1200" dirty="0"/>
+              <a:t>Tamburello in feltro cammello</a:t>
+            </a:r>
+            <a:endParaRPr lang="en-US" sz="1150" dirty="0"/>
           </a:p>
         </p:txBody>
       </p:sp>
       <p:pic>
         <p:nvPicPr>
-          <p:cNvPr id="7" name="Image 1" descr="img/hat2.jpg">    </p:cNvPr>
+          <p:cNvPr id="7" name="Image 1" descr="img/prod1.jpg">    </p:cNvPr>
           <p:cNvPicPr>
             <a:picLocks noChangeAspect="1"/>
           </p:cNvPicPr>
@@ -9375,13 +9375,13 @@
         </p:nvPicPr>
         <p:blipFill>
           <a:blip r:embed="rId2"/>
-          <a:srcRect l="0" r="0" t="10714" b="10714"/>
+          <a:srcRect l="0" r="0" t="51" b="41"/>
           <a:stretch/>
         </p:blipFill>
         <p:spPr>
           <a:xfrm>
-            <a:off x="3520440" y="2606040"/>
-            <a:ext cx="2560320" cy="3017520"/>
+            <a:off x="2898648" y="2697480"/>
+            <a:ext cx="1984248" cy="2478024"/>
           </a:xfrm>
           <a:prstGeom prst="rect">
             <a:avLst/>
@@ -9396,8 +9396,8 @@
         </p:nvSpPr>
         <p:spPr>
           <a:xfrm>
-            <a:off x="3520440" y="5760720"/>
-            <a:ext cx="2560320" cy="320040"/>
+            <a:off x="2898648" y="5303520"/>
+            <a:ext cx="1984248" cy="457200"/>
           </a:xfrm>
           <a:prstGeom prst="rect">
             <a:avLst/>
@@ -9419,7 +9419,7 @@
               <a:buNone/>
             </a:pPr>
             <a:r>
-              <a:rPr lang="en-US" sz="1200" dirty="0">
+              <a:rPr lang="en-US" sz="1150" dirty="0">
                 <a:solidFill>
                   <a:srgbClr val="DCDDDC"/>
                 </a:solidFill>
@@ -9427,15 +9427,15 @@
                 <a:ea typeface="Arial" pitchFamily="34" charset="-122"/>
                 <a:cs typeface="Arial" pitchFamily="34" charset="-120"/>
               </a:rPr>
-              <a:t>Fedora in feltro verde bosco</a:t>
-            </a:r>
-            <a:endParaRPr lang="en-US" sz="1200" dirty="0"/>
+              <a:t>Fedora in feltro maculato</a:t>
+            </a:r>
+            <a:endParaRPr lang="en-US" sz="1150" dirty="0"/>
           </a:p>
         </p:txBody>
       </p:sp>
       <p:pic>
         <p:nvPicPr>
-          <p:cNvPr id="9" name="Image 2" descr="img/hat3.jpg">    </p:cNvPr>
+          <p:cNvPr id="9" name="Image 2" descr="img/prod2.jpg">    </p:cNvPr>
           <p:cNvPicPr>
             <a:picLocks noChangeAspect="1"/>
           </p:cNvPicPr>
@@ -9443,13 +9443,13 @@
         </p:nvPicPr>
         <p:blipFill>
           <a:blip r:embed="rId3"/>
-          <a:srcRect l="7576" r="7576" t="0" b="0"/>
+          <a:srcRect l="0" r="0" t="51" b="41"/>
           <a:stretch/>
         </p:blipFill>
         <p:spPr>
           <a:xfrm>
-            <a:off x="6355080" y="2606040"/>
-            <a:ext cx="2560320" cy="3017520"/>
+            <a:off x="5111496" y="2697480"/>
+            <a:ext cx="1984248" cy="2478024"/>
           </a:xfrm>
           <a:prstGeom prst="rect">
             <a:avLst/>
@@ -9464,8 +9464,8 @@
         </p:nvSpPr>
         <p:spPr>
           <a:xfrm>
-            <a:off x="6355080" y="5760720"/>
-            <a:ext cx="2560320" cy="320040"/>
+            <a:off x="5111496" y="5303520"/>
+            <a:ext cx="1984248" cy="457200"/>
           </a:xfrm>
           <a:prstGeom prst="rect">
             <a:avLst/>
@@ -9487,7 +9487,7 @@
               <a:buNone/>
             </a:pPr>
             <a:r>
-              <a:rPr lang="en-US" sz="1200" dirty="0">
+              <a:rPr lang="en-US" sz="1150" dirty="0">
                 <a:solidFill>
                   <a:srgbClr val="DCDDDC"/>
                 </a:solidFill>
@@ -9495,15 +9495,15 @@
                 <a:ea typeface="Arial" pitchFamily="34" charset="-122"/>
                 <a:cs typeface="Arial" pitchFamily="34" charset="-120"/>
               </a:rPr>
-              <a:t>Fedora nero con catena</a:t>
-            </a:r>
-            <a:endParaRPr lang="en-US" sz="1200" dirty="0"/>
+              <a:t>Cloche in feltro prugna</a:t>
+            </a:r>
+            <a:endParaRPr lang="en-US" sz="1150" dirty="0"/>
           </a:p>
         </p:txBody>
       </p:sp>
       <p:pic>
         <p:nvPicPr>
-          <p:cNvPr id="11" name="Image 3" descr="img/hat4.jpg">    </p:cNvPr>
+          <p:cNvPr id="11" name="Image 3" descr="img/prod3.jpg">    </p:cNvPr>
           <p:cNvPicPr>
             <a:picLocks noChangeAspect="1"/>
           </p:cNvPicPr>
@@ -9511,13 +9511,13 @@
         </p:nvPicPr>
         <p:blipFill>
           <a:blip r:embed="rId4"/>
-          <a:srcRect l="0" r="0" t="10685" b="10685"/>
+          <a:srcRect l="0" r="0" t="51" b="41"/>
           <a:stretch/>
         </p:blipFill>
         <p:spPr>
           <a:xfrm>
-            <a:off x="9189720" y="2606040"/>
-            <a:ext cx="2560320" cy="3017520"/>
+            <a:off x="7324344" y="2697480"/>
+            <a:ext cx="1984248" cy="2478024"/>
           </a:xfrm>
           <a:prstGeom prst="rect">
             <a:avLst/>
@@ -9532,8 +9532,8 @@
         </p:nvSpPr>
         <p:spPr>
           <a:xfrm>
-            <a:off x="9189720" y="5760720"/>
-            <a:ext cx="2560320" cy="320040"/>
+            <a:off x="7324344" y="5303520"/>
+            <a:ext cx="1984248" cy="457200"/>
           </a:xfrm>
           <a:prstGeom prst="rect">
             <a:avLst/>
@@ -9555,7 +9555,7 @@
               <a:buNone/>
             </a:pPr>
             <a:r>
-              <a:rPr lang="en-US" sz="1200" dirty="0">
+              <a:rPr lang="en-US" sz="1150" dirty="0">
                 <a:solidFill>
                   <a:srgbClr val="DCDDDC"/>
                 </a:solidFill>
@@ -9563,22 +9563,45 @@
                 <a:ea typeface="Arial" pitchFamily="34" charset="-122"/>
                 <a:cs typeface="Arial" pitchFamily="34" charset="-120"/>
               </a:rPr>
-              <a:t>Basco in pelle rosso</a:t>
-            </a:r>
-            <a:endParaRPr lang="en-US" sz="1200" dirty="0"/>
-          </a:p>
-        </p:txBody>
-      </p:sp>
-      <p:sp>
-        <p:nvSpPr>
-          <p:cNvPr id="13" name="Text 7"/>
-          <p:cNvSpPr txBox="1"/>
-          <p:nvPr/>
-        </p:nvSpPr>
-        <p:spPr>
-          <a:xfrm>
-            <a:off x="685800" y="6172200"/>
-            <a:ext cx="10058400" cy="274320"/>
+              <a:t>Cloche leopardata con fiocco</a:t>
+            </a:r>
+            <a:endParaRPr lang="en-US" sz="1150" dirty="0"/>
+          </a:p>
+        </p:txBody>
+      </p:sp>
+      <p:pic>
+        <p:nvPicPr>
+          <p:cNvPr id="13" name="Image 4" descr="img/prod4.jpg">    </p:cNvPr>
+          <p:cNvPicPr>
+            <a:picLocks noChangeAspect="1"/>
+          </p:cNvPicPr>
+          <p:nvPr/>
+        </p:nvPicPr>
+        <p:blipFill>
+          <a:blip r:embed="rId5"/>
+          <a:srcRect l="0" r="0" t="51" b="41"/>
+          <a:stretch/>
+        </p:blipFill>
+        <p:spPr>
+          <a:xfrm>
+            <a:off x="9537192" y="2697480"/>
+            <a:ext cx="1984248" cy="2478024"/>
+          </a:xfrm>
+          <a:prstGeom prst="rect">
+            <a:avLst/>
+          </a:prstGeom>
+        </p:spPr>
+      </p:pic>
+      <p:sp>
+        <p:nvSpPr>
+          <p:cNvPr id="14" name="Text 7"/>
+          <p:cNvSpPr txBox="1"/>
+          <p:nvPr/>
+        </p:nvSpPr>
+        <p:spPr>
+          <a:xfrm>
+            <a:off x="9537192" y="5303520"/>
+            <a:ext cx="1984248" cy="457200"/>
           </a:xfrm>
           <a:prstGeom prst="rect">
             <a:avLst/>
@@ -9600,17 +9623,17 @@
               <a:buNone/>
             </a:pPr>
             <a:r>
-              <a:rPr lang="en-US" sz="1000" dirty="0">
-                <a:solidFill>
-                  <a:srgbClr val="8A8D90"/>
-                </a:solidFill>
-                <a:latin typeface="Arial" pitchFamily="34" charset="0"/>
-                <a:ea typeface="Arial" pitchFamily="34" charset="-122"/>
-                <a:cs typeface="Arial" pitchFamily="34" charset="-120"/>
-              </a:rPr>
-              <a:t>Modelli dal catalogo attuale, come esempio. La selezione seguirà la collezione A/I 2026–27.</a:t>
-            </a:r>
-            <a:endParaRPr lang="en-US" sz="1000" dirty="0"/>
+              <a:rPr lang="en-US" sz="1150" dirty="0">
+                <a:solidFill>
+                  <a:srgbClr val="DCDDDC"/>
+                </a:solidFill>
+                <a:latin typeface="Arial" pitchFamily="34" charset="0"/>
+                <a:ea typeface="Arial" pitchFamily="34" charset="-122"/>
+                <a:cs typeface="Arial" pitchFamily="34" charset="-120"/>
+              </a:rPr>
+              <a:t>Coppola in feltro ricamata</a:t>
+            </a:r>
+            <a:endParaRPr lang="en-US" sz="1150" dirty="0"/>
           </a:p>
         </p:txBody>
       </p:sp>

</xml_diff>

<commit_message>
Deck Tirabasso v2: Torino come alternativa a Parigi
Una slide con le sette scene riportate su location di Torino e una di
confronto tra Torino, Lione, Trieste e Milano.

Co-Authored-By: Claude Opus 5.5 <noreply@anthropic.com>
Claude-Session: https://claude.ai/code/session_019CimPMJNPswxhYiugHUDKX
</commit_message>
<xml_diff>
--- a/tirabasso/campagna-fw26-27/Tirabasso_Un_hiver_a_Paris_v2.pptx
+++ b/tirabasso/campagna-fw26-27/Tirabasso_Un_hiver_a_Paris_v2.pptx
@@ -20,9 +20,11 @@
     <p:sldId id="268" r:id="rId14"/>
     <p:sldId id="269" r:id="rId15"/>
     <p:sldId id="270" r:id="rId16"/>
+    <p:sldId id="271" r:id="rId17"/>
+    <p:sldId id="272" r:id="rId18"/>
   </p:sldIdLst>
   <p:notesMasterIdLst>
-    <p:notesMasterId r:id="rId17"/>
+    <p:notesMasterId r:id="rId19"/>
   </p:notesMasterIdLst>
   <p:sldSz cx="12192000" cy="6858000"/>
   <p:notesSz cx="6858000" cy="12192000"/>
@@ -956,7 +958,7 @@
           <a:p>
             <a:r>
               <a:rPr lang="en-US" dirty="0"/>
-              <a:t>Tempi, troupe e consegne sono una proposta di partenza, da definire con il cliente e il budget.</a:t>
+              <a:t>Immagine: riferimento dalla cartella di ricerca, non uno scatto di Torino.</a:t>
             </a:r>
             <a:endParaRPr lang="en-US" dirty="0"/>
           </a:p>
@@ -1068,6 +1070,182 @@
             <a:fld id="{F7021451-1387-4CA6-816F-3879F97B5CBC}" type="slidenum">
               <a:rPr lang="en-US"/>
               <a:t>15</a:t>
+            </a:fld>
+            <a:endParaRPr lang="en-US"/>
+          </a:p>
+        </p:txBody>
+      </p:sp>
+    </p:spTree>
+    <p:extLst>
+      <p:ext uri="{BB962C8B-B14F-4D97-AF65-F5344CB8AC3E}">
+        <p14:creationId xmlns:p14="http://schemas.microsoft.com/office/powerpoint/2010/main" val="1024086991"/>
+      </p:ext>
+    </p:extLst>
+  </p:cSld>
+  <p:clrMapOvr>
+    <a:masterClrMapping/>
+  </p:clrMapOvr>
+</p:notes>
+</file>
+
+<file path=ppt/notesSlides/notesSlide16.xml><?xml version="1.0" encoding="utf-8"?>
+<p:notes xmlns:a="http://schemas.openxmlformats.org/drawingml/2006/main" xmlns:r="http://schemas.openxmlformats.org/officeDocument/2006/relationships" xmlns:p="http://schemas.openxmlformats.org/presentationml/2006/main">
+  <p:cSld>
+    <p:spTree>
+      <p:nvGrpSpPr>
+        <p:cNvPr id="1" name=""/>
+        <p:cNvGrpSpPr/>
+        <p:nvPr/>
+      </p:nvGrpSpPr>
+      <p:grpSpPr>
+        <a:xfrm>
+          <a:off x="0" y="0"/>
+          <a:ext cx="0" cy="0"/>
+          <a:chOff x="0" y="0"/>
+          <a:chExt cx="0" cy="0"/>
+        </a:xfrm>
+      </p:grpSpPr>
+      <p:sp>
+        <p:nvSpPr>
+          <p:cNvPr id="2" name="Slide Image Placeholder 1"/>
+          <p:cNvSpPr>
+            <a:spLocks noGrp="1" noRot="1" noChangeAspect="1"/>
+          </p:cNvSpPr>
+          <p:nvPr>
+            <p:ph type="sldImg"/>
+          </p:nvPr>
+        </p:nvSpPr>
+        <p:spPr/>
+      </p:sp>
+      <p:sp>
+        <p:nvSpPr>
+          <p:cNvPr id="3" name="Notes Placeholder 2"/>
+          <p:cNvSpPr>
+            <a:spLocks noGrp="1"/>
+          </p:cNvSpPr>
+          <p:nvPr>
+            <p:ph type="body" idx="1"/>
+          </p:nvPr>
+        </p:nvSpPr>
+        <p:spPr/>
+        <p:txBody>
+          <a:bodyPr/>
+          <a:lstStyle/>
+          <a:p>
+            <a:r>
+              <a:rPr lang="en-US" dirty="0"/>
+              <a:t>Tempi, troupe e consegne sono una proposta di partenza, da definire con il cliente e il budget.</a:t>
+            </a:r>
+            <a:endParaRPr lang="en-US" dirty="0"/>
+          </a:p>
+        </p:txBody>
+      </p:sp>
+      <p:sp>
+        <p:nvSpPr>
+          <p:cNvPr id="4" name="Slide Number Placeholder 3"/>
+          <p:cNvSpPr>
+            <a:spLocks noGrp="1"/>
+          </p:cNvSpPr>
+          <p:nvPr>
+            <p:ph type="sldNum" sz="quarter" idx="10"/>
+          </p:nvPr>
+        </p:nvSpPr>
+        <p:spPr/>
+        <p:txBody>
+          <a:bodyPr/>
+          <a:lstStyle/>
+          <a:p>
+            <a:fld id="{F7021451-1387-4CA6-816F-3879F97B5CBC}" type="slidenum">
+              <a:rPr lang="en-US"/>
+              <a:t>16</a:t>
+            </a:fld>
+            <a:endParaRPr lang="en-US"/>
+          </a:p>
+        </p:txBody>
+      </p:sp>
+    </p:spTree>
+    <p:extLst>
+      <p:ext uri="{BB962C8B-B14F-4D97-AF65-F5344CB8AC3E}">
+        <p14:creationId xmlns:p14="http://schemas.microsoft.com/office/powerpoint/2010/main" val="1024086991"/>
+      </p:ext>
+    </p:extLst>
+  </p:cSld>
+  <p:clrMapOvr>
+    <a:masterClrMapping/>
+  </p:clrMapOvr>
+</p:notes>
+</file>
+
+<file path=ppt/notesSlides/notesSlide17.xml><?xml version="1.0" encoding="utf-8"?>
+<p:notes xmlns:a="http://schemas.openxmlformats.org/drawingml/2006/main" xmlns:r="http://schemas.openxmlformats.org/officeDocument/2006/relationships" xmlns:p="http://schemas.openxmlformats.org/presentationml/2006/main">
+  <p:cSld>
+    <p:spTree>
+      <p:nvGrpSpPr>
+        <p:cNvPr id="1" name=""/>
+        <p:cNvGrpSpPr/>
+        <p:nvPr/>
+      </p:nvGrpSpPr>
+      <p:grpSpPr>
+        <a:xfrm>
+          <a:off x="0" y="0"/>
+          <a:ext cx="0" cy="0"/>
+          <a:chOff x="0" y="0"/>
+          <a:chExt cx="0" cy="0"/>
+        </a:xfrm>
+      </p:grpSpPr>
+      <p:sp>
+        <p:nvSpPr>
+          <p:cNvPr id="2" name="Slide Image Placeholder 1"/>
+          <p:cNvSpPr>
+            <a:spLocks noGrp="1" noRot="1" noChangeAspect="1"/>
+          </p:cNvSpPr>
+          <p:nvPr>
+            <p:ph type="sldImg"/>
+          </p:nvPr>
+        </p:nvSpPr>
+        <p:spPr/>
+      </p:sp>
+      <p:sp>
+        <p:nvSpPr>
+          <p:cNvPr id="3" name="Notes Placeholder 2"/>
+          <p:cNvSpPr>
+            <a:spLocks noGrp="1"/>
+          </p:cNvSpPr>
+          <p:nvPr>
+            <p:ph type="body" idx="1"/>
+          </p:nvPr>
+        </p:nvSpPr>
+        <p:spPr/>
+        <p:txBody>
+          <a:bodyPr/>
+          <a:lstStyle/>
+          <a:p>
+            <a:r>
+              <a:rPr lang="en-US" dirty="0"/>
+              <a:t/>
+            </a:r>
+            <a:endParaRPr lang="en-US" dirty="0"/>
+          </a:p>
+        </p:txBody>
+      </p:sp>
+      <p:sp>
+        <p:nvSpPr>
+          <p:cNvPr id="4" name="Slide Number Placeholder 3"/>
+          <p:cNvSpPr>
+            <a:spLocks noGrp="1"/>
+          </p:cNvSpPr>
+          <p:nvPr>
+            <p:ph type="sldNum" sz="quarter" idx="10"/>
+          </p:nvPr>
+        </p:nvSpPr>
+        <p:spPr/>
+        <p:txBody>
+          <a:bodyPr/>
+          <a:lstStyle/>
+          <a:p>
+            <a:fld id="{F7021451-1387-4CA6-816F-3879F97B5CBC}" type="slidenum">
+              <a:rPr lang="en-US"/>
+              <a:t>17</a:t>
             </a:fld>
             <a:endParaRPr lang="en-US"/>
           </a:p>
@@ -5485,6 +5663,955 @@
     <p:bg>
       <p:bgPr>
         <a:solidFill>
+          <a:srgbClr val="FFFFFF"/>
+        </a:solidFill>
+      </p:bgPr>
+    </p:bg>
+    <p:spTree>
+      <p:nvGrpSpPr>
+        <p:cNvPr id="1" name=""/>
+        <p:cNvGrpSpPr/>
+        <p:nvPr/>
+      </p:nvGrpSpPr>
+      <p:grpSpPr>
+        <a:xfrm>
+          <a:off x="0" y="0"/>
+          <a:ext cx="0" cy="0"/>
+          <a:chOff x="0" y="0"/>
+          <a:chExt cx="0" cy="0"/>
+        </a:xfrm>
+      </p:grpSpPr>
+      <p:pic>
+        <p:nvPicPr>
+          <p:cNvPr id="2" name="Image 0" descr="img/column.jpg">    </p:cNvPr>
+          <p:cNvPicPr>
+            <a:picLocks noChangeAspect="1"/>
+          </p:cNvPicPr>
+          <p:nvPr/>
+        </p:nvPicPr>
+        <p:blipFill>
+          <a:blip r:embed="rId1"/>
+          <a:srcRect l="10519" r="24543" t="0" b="0"/>
+          <a:stretch/>
+        </p:blipFill>
+        <p:spPr>
+          <a:xfrm>
+            <a:off x="8899855" y="0"/>
+            <a:ext cx="3291840" cy="6858000"/>
+          </a:xfrm>
+          <a:prstGeom prst="rect">
+            <a:avLst/>
+          </a:prstGeom>
+        </p:spPr>
+      </p:pic>
+      <p:sp>
+        <p:nvSpPr>
+          <p:cNvPr id="3" name="Text 0"/>
+          <p:cNvSpPr txBox="1"/>
+          <p:nvPr/>
+        </p:nvSpPr>
+        <p:spPr>
+          <a:xfrm>
+            <a:off x="685800" y="548640"/>
+            <a:ext cx="5486400" cy="274320"/>
+          </a:xfrm>
+          <a:prstGeom prst="rect">
+            <a:avLst/>
+          </a:prstGeom>
+          <a:noFill/>
+          <a:ln/>
+        </p:spPr>
+        <p:txBody>
+          <a:bodyPr wrap="square" lIns="0" tIns="0" rIns="0" bIns="0" rtlCol="0" anchor="ctr"/>
+          <a:lstStyle/>
+          <a:p>
+            <a:pPr indent="0" marL="0">
+              <a:buNone/>
+            </a:pPr>
+            <a:r>
+              <a:rPr lang="en-US" sz="1000" spc="400" kern="0" dirty="0">
+                <a:solidFill>
+                  <a:srgbClr val="5E6266"/>
+                </a:solidFill>
+                <a:latin typeface="Arial" pitchFamily="34" charset="0"/>
+                <a:ea typeface="Arial" pitchFamily="34" charset="-122"/>
+                <a:cs typeface="Arial" pitchFamily="34" charset="-120"/>
+              </a:rPr>
+              <a:t>08 — ALTERNATIVA A PARIGI</a:t>
+            </a:r>
+            <a:endParaRPr lang="en-US" sz="1000" dirty="0"/>
+          </a:p>
+        </p:txBody>
+      </p:sp>
+      <p:sp>
+        <p:nvSpPr>
+          <p:cNvPr id="4" name="Text 1"/>
+          <p:cNvSpPr txBox="1"/>
+          <p:nvPr/>
+        </p:nvSpPr>
+        <p:spPr>
+          <a:xfrm>
+            <a:off x="685800" y="868680"/>
+            <a:ext cx="7680960" cy="731520"/>
+          </a:xfrm>
+          <a:prstGeom prst="rect">
+            <a:avLst/>
+          </a:prstGeom>
+          <a:noFill/>
+          <a:ln/>
+        </p:spPr>
+        <p:txBody>
+          <a:bodyPr wrap="square" lIns="0" tIns="0" rIns="0" bIns="0" rtlCol="0" anchor="t"/>
+          <a:lstStyle/>
+          <a:p>
+            <a:pPr indent="0" marL="0">
+              <a:buNone/>
+            </a:pPr>
+            <a:r>
+              <a:rPr lang="en-US" sz="3200" dirty="0">
+                <a:solidFill>
+                  <a:srgbClr val="1E2023"/>
+                </a:solidFill>
+                <a:latin typeface="Cambria" pitchFamily="34" charset="0"/>
+                <a:ea typeface="Cambria" pitchFamily="34" charset="-122"/>
+                <a:cs typeface="Cambria" pitchFamily="34" charset="-120"/>
+              </a:rPr>
+              <a:t>Torino, la più parigina d’Italia</a:t>
+            </a:r>
+            <a:endParaRPr lang="en-US" sz="3200" dirty="0"/>
+          </a:p>
+        </p:txBody>
+      </p:sp>
+      <p:sp>
+        <p:nvSpPr>
+          <p:cNvPr id="5" name="Text 2"/>
+          <p:cNvSpPr txBox="1"/>
+          <p:nvPr/>
+        </p:nvSpPr>
+        <p:spPr>
+          <a:xfrm>
+            <a:off x="685800" y="1600200"/>
+            <a:ext cx="7772400" cy="731520"/>
+          </a:xfrm>
+          <a:prstGeom prst="rect">
+            <a:avLst/>
+          </a:prstGeom>
+          <a:noFill/>
+          <a:ln/>
+        </p:spPr>
+        <p:txBody>
+          <a:bodyPr wrap="square" lIns="0" tIns="0" rIns="0" bIns="0" rtlCol="0" anchor="t"/>
+          <a:lstStyle/>
+          <a:p>
+            <a:pPr indent="0" marL="0">
+              <a:lnSpc>
+                <a:spcPct val="115000"/>
+              </a:lnSpc>
+              <a:spcAft>
+                <a:spcPts val="600"/>
+              </a:spcAft>
+              <a:buNone/>
+            </a:pPr>
+            <a:r>
+              <a:rPr lang="en-US" sz="1300" dirty="0">
+                <a:solidFill>
+                  <a:srgbClr val="5E6266"/>
+                </a:solidFill>
+                <a:latin typeface="Arial" pitchFamily="34" charset="0"/>
+                <a:ea typeface="Arial" pitchFamily="34" charset="-122"/>
+                <a:cs typeface="Arial" pitchFamily="34" charset="-120"/>
+              </a:rPr>
+              <a:t>Portici, caffè storici, palazzi barocchi e liberty, e d’inverno la nebbia che sale dal Po. Il racconto resta lo stesso, con costi e logistica italiani: niente trasferte all’estero, troupe e permessi locali.</a:t>
+            </a:r>
+            <a:endParaRPr lang="en-US" sz="1300" dirty="0"/>
+          </a:p>
+        </p:txBody>
+      </p:sp>
+      <p:sp>
+        <p:nvSpPr>
+          <p:cNvPr id="6" name="Text 3"/>
+          <p:cNvSpPr txBox="1"/>
+          <p:nvPr/>
+        </p:nvSpPr>
+        <p:spPr>
+          <a:xfrm>
+            <a:off x="685800" y="2514600"/>
+            <a:ext cx="2103120" cy="384048"/>
+          </a:xfrm>
+          <a:prstGeom prst="rect">
+            <a:avLst/>
+          </a:prstGeom>
+          <a:noFill/>
+          <a:ln/>
+        </p:spPr>
+        <p:txBody>
+          <a:bodyPr wrap="square" lIns="0" tIns="0" rIns="0" bIns="0" rtlCol="0" anchor="ctr"/>
+          <a:lstStyle/>
+          <a:p>
+            <a:pPr indent="0" marL="0">
+              <a:buNone/>
+            </a:pPr>
+            <a:r>
+              <a:rPr lang="en-US" sz="1400" i="1" dirty="0">
+                <a:solidFill>
+                  <a:srgbClr val="1E2023"/>
+                </a:solidFill>
+                <a:latin typeface="Cambria" pitchFamily="34" charset="0"/>
+                <a:ea typeface="Cambria" pitchFamily="34" charset="-122"/>
+                <a:cs typeface="Cambria" pitchFamily="34" charset="-120"/>
+              </a:rPr>
+              <a:t>Uscita e strade</a:t>
+            </a:r>
+            <a:endParaRPr lang="en-US" sz="1400" dirty="0"/>
+          </a:p>
+        </p:txBody>
+      </p:sp>
+      <p:sp>
+        <p:nvSpPr>
+          <p:cNvPr id="7" name="Text 4"/>
+          <p:cNvSpPr txBox="1"/>
+          <p:nvPr/>
+        </p:nvSpPr>
+        <p:spPr>
+          <a:xfrm>
+            <a:off x="2834640" y="2514600"/>
+            <a:ext cx="5623560" cy="384048"/>
+          </a:xfrm>
+          <a:prstGeom prst="rect">
+            <a:avLst/>
+          </a:prstGeom>
+          <a:noFill/>
+          <a:ln/>
+        </p:spPr>
+        <p:txBody>
+          <a:bodyPr wrap="square" lIns="0" tIns="0" rIns="0" bIns="0" rtlCol="0" anchor="ctr"/>
+          <a:lstStyle/>
+          <a:p>
+            <a:pPr indent="0" marL="0">
+              <a:lnSpc>
+                <a:spcPct val="115000"/>
+              </a:lnSpc>
+              <a:spcAft>
+                <a:spcPts val="600"/>
+              </a:spcAft>
+              <a:buNone/>
+            </a:pPr>
+            <a:r>
+              <a:rPr lang="en-US" sz="1150" dirty="0">
+                <a:solidFill>
+                  <a:srgbClr val="5E6266"/>
+                </a:solidFill>
+                <a:latin typeface="Arial" pitchFamily="34" charset="0"/>
+                <a:ea typeface="Arial" pitchFamily="34" charset="-122"/>
+                <a:cs typeface="Arial" pitchFamily="34" charset="-120"/>
+              </a:rPr>
+              <a:t>Via Po, Borgo Nuovo, Crocetta</a:t>
+            </a:r>
+            <a:endParaRPr lang="en-US" sz="1150" dirty="0"/>
+          </a:p>
+        </p:txBody>
+      </p:sp>
+      <p:sp>
+        <p:nvSpPr>
+          <p:cNvPr id="8" name="Shape 5"/>
+          <p:cNvSpPr/>
+          <p:nvPr/>
+        </p:nvSpPr>
+        <p:spPr>
+          <a:xfrm>
+            <a:off x="685800" y="2953512"/>
+            <a:ext cx="7772400" cy="0"/>
+          </a:xfrm>
+          <a:prstGeom prst="line">
+            <a:avLst/>
+          </a:prstGeom>
+          <a:noFill/>
+          <a:ln w="9525">
+            <a:solidFill>
+              <a:srgbClr val="DCDDDC"/>
+            </a:solidFill>
+            <a:prstDash val="solid"/>
+          </a:ln>
+        </p:spPr>
+      </p:sp>
+      <p:sp>
+        <p:nvSpPr>
+          <p:cNvPr id="9" name="Text 6"/>
+          <p:cNvSpPr txBox="1"/>
+          <p:nvPr/>
+        </p:nvSpPr>
+        <p:spPr>
+          <a:xfrm>
+            <a:off x="685800" y="3026664"/>
+            <a:ext cx="2103120" cy="384048"/>
+          </a:xfrm>
+          <a:prstGeom prst="rect">
+            <a:avLst/>
+          </a:prstGeom>
+          <a:noFill/>
+          <a:ln/>
+        </p:spPr>
+        <p:txBody>
+          <a:bodyPr wrap="square" lIns="0" tIns="0" rIns="0" bIns="0" rtlCol="0" anchor="ctr"/>
+          <a:lstStyle/>
+          <a:p>
+            <a:pPr indent="0" marL="0">
+              <a:buNone/>
+            </a:pPr>
+            <a:r>
+              <a:rPr lang="en-US" sz="1400" i="1" dirty="0">
+                <a:solidFill>
+                  <a:srgbClr val="1E2023"/>
+                </a:solidFill>
+                <a:latin typeface="Cambria" pitchFamily="34" charset="0"/>
+                <a:ea typeface="Cambria" pitchFamily="34" charset="-122"/>
+                <a:cs typeface="Cambria" pitchFamily="34" charset="-120"/>
+              </a:rPr>
+              <a:t>Attraversamento</a:t>
+            </a:r>
+            <a:endParaRPr lang="en-US" sz="1400" dirty="0"/>
+          </a:p>
+        </p:txBody>
+      </p:sp>
+      <p:sp>
+        <p:nvSpPr>
+          <p:cNvPr id="10" name="Text 7"/>
+          <p:cNvSpPr txBox="1"/>
+          <p:nvPr/>
+        </p:nvSpPr>
+        <p:spPr>
+          <a:xfrm>
+            <a:off x="2834640" y="3026664"/>
+            <a:ext cx="5623560" cy="384048"/>
+          </a:xfrm>
+          <a:prstGeom prst="rect">
+            <a:avLst/>
+          </a:prstGeom>
+          <a:noFill/>
+          <a:ln/>
+        </p:spPr>
+        <p:txBody>
+          <a:bodyPr wrap="square" lIns="0" tIns="0" rIns="0" bIns="0" rtlCol="0" anchor="ctr"/>
+          <a:lstStyle/>
+          <a:p>
+            <a:pPr indent="0" marL="0">
+              <a:lnSpc>
+                <a:spcPct val="115000"/>
+              </a:lnSpc>
+              <a:spcAft>
+                <a:spcPts val="600"/>
+              </a:spcAft>
+              <a:buNone/>
+            </a:pPr>
+            <a:r>
+              <a:rPr lang="en-US" sz="1150" dirty="0">
+                <a:solidFill>
+                  <a:srgbClr val="5E6266"/>
+                </a:solidFill>
+                <a:latin typeface="Arial" pitchFamily="34" charset="0"/>
+                <a:ea typeface="Arial" pitchFamily="34" charset="-122"/>
+                <a:cs typeface="Arial" pitchFamily="34" charset="-120"/>
+              </a:rPr>
+              <a:t>Piazza Castello, Piazza Vittorio Veneto, Corso Vittorio Emanuele II</a:t>
+            </a:r>
+            <a:endParaRPr lang="en-US" sz="1150" dirty="0"/>
+          </a:p>
+        </p:txBody>
+      </p:sp>
+      <p:sp>
+        <p:nvSpPr>
+          <p:cNvPr id="11" name="Shape 8"/>
+          <p:cNvSpPr/>
+          <p:nvPr/>
+        </p:nvSpPr>
+        <p:spPr>
+          <a:xfrm>
+            <a:off x="685800" y="3465576"/>
+            <a:ext cx="7772400" cy="0"/>
+          </a:xfrm>
+          <a:prstGeom prst="line">
+            <a:avLst/>
+          </a:prstGeom>
+          <a:noFill/>
+          <a:ln w="9525">
+            <a:solidFill>
+              <a:srgbClr val="DCDDDC"/>
+            </a:solidFill>
+            <a:prstDash val="solid"/>
+          </a:ln>
+        </p:spPr>
+      </p:sp>
+      <p:sp>
+        <p:nvSpPr>
+          <p:cNvPr id="12" name="Text 9"/>
+          <p:cNvSpPr txBox="1"/>
+          <p:nvPr/>
+        </p:nvSpPr>
+        <p:spPr>
+          <a:xfrm>
+            <a:off x="685800" y="3538728"/>
+            <a:ext cx="2103120" cy="384048"/>
+          </a:xfrm>
+          <a:prstGeom prst="rect">
+            <a:avLst/>
+          </a:prstGeom>
+          <a:noFill/>
+          <a:ln/>
+        </p:spPr>
+        <p:txBody>
+          <a:bodyPr wrap="square" lIns="0" tIns="0" rIns="0" bIns="0" rtlCol="0" anchor="ctr"/>
+          <a:lstStyle/>
+          <a:p>
+            <a:pPr indent="0" marL="0">
+              <a:buNone/>
+            </a:pPr>
+            <a:r>
+              <a:rPr lang="en-US" sz="1400" i="1" dirty="0">
+                <a:solidFill>
+                  <a:srgbClr val="1E2023"/>
+                </a:solidFill>
+                <a:latin typeface="Cambria" pitchFamily="34" charset="0"/>
+                <a:ea typeface="Cambria" pitchFamily="34" charset="-122"/>
+                <a:cs typeface="Cambria" pitchFamily="34" charset="-120"/>
+              </a:rPr>
+              <a:t>Caffè</a:t>
+            </a:r>
+            <a:endParaRPr lang="en-US" sz="1400" dirty="0"/>
+          </a:p>
+        </p:txBody>
+      </p:sp>
+      <p:sp>
+        <p:nvSpPr>
+          <p:cNvPr id="13" name="Text 10"/>
+          <p:cNvSpPr txBox="1"/>
+          <p:nvPr/>
+        </p:nvSpPr>
+        <p:spPr>
+          <a:xfrm>
+            <a:off x="2834640" y="3538728"/>
+            <a:ext cx="5623560" cy="384048"/>
+          </a:xfrm>
+          <a:prstGeom prst="rect">
+            <a:avLst/>
+          </a:prstGeom>
+          <a:noFill/>
+          <a:ln/>
+        </p:spPr>
+        <p:txBody>
+          <a:bodyPr wrap="square" lIns="0" tIns="0" rIns="0" bIns="0" rtlCol="0" anchor="ctr"/>
+          <a:lstStyle/>
+          <a:p>
+            <a:pPr indent="0" marL="0">
+              <a:lnSpc>
+                <a:spcPct val="115000"/>
+              </a:lnSpc>
+              <a:spcAft>
+                <a:spcPts val="600"/>
+              </a:spcAft>
+              <a:buNone/>
+            </a:pPr>
+            <a:r>
+              <a:rPr lang="en-US" sz="1150" dirty="0">
+                <a:solidFill>
+                  <a:srgbClr val="5E6266"/>
+                </a:solidFill>
+                <a:latin typeface="Arial" pitchFamily="34" charset="0"/>
+                <a:ea typeface="Arial" pitchFamily="34" charset="-122"/>
+                <a:cs typeface="Arial" pitchFamily="34" charset="-120"/>
+              </a:rPr>
+              <a:t>Caffè Mulassano, Al Bicerin, Caffè San Carlo, Baratti &amp; Milano</a:t>
+            </a:r>
+            <a:endParaRPr lang="en-US" sz="1150" dirty="0"/>
+          </a:p>
+        </p:txBody>
+      </p:sp>
+      <p:sp>
+        <p:nvSpPr>
+          <p:cNvPr id="14" name="Shape 11"/>
+          <p:cNvSpPr/>
+          <p:nvPr/>
+        </p:nvSpPr>
+        <p:spPr>
+          <a:xfrm>
+            <a:off x="685800" y="3977640"/>
+            <a:ext cx="7772400" cy="0"/>
+          </a:xfrm>
+          <a:prstGeom prst="line">
+            <a:avLst/>
+          </a:prstGeom>
+          <a:noFill/>
+          <a:ln w="9525">
+            <a:solidFill>
+              <a:srgbClr val="DCDDDC"/>
+            </a:solidFill>
+            <a:prstDash val="solid"/>
+          </a:ln>
+        </p:spPr>
+      </p:sp>
+      <p:sp>
+        <p:nvSpPr>
+          <p:cNvPr id="15" name="Text 12"/>
+          <p:cNvSpPr txBox="1"/>
+          <p:nvPr/>
+        </p:nvSpPr>
+        <p:spPr>
+          <a:xfrm>
+            <a:off x="685800" y="4050792"/>
+            <a:ext cx="2103120" cy="384048"/>
+          </a:xfrm>
+          <a:prstGeom prst="rect">
+            <a:avLst/>
+          </a:prstGeom>
+          <a:noFill/>
+          <a:ln/>
+        </p:spPr>
+        <p:txBody>
+          <a:bodyPr wrap="square" lIns="0" tIns="0" rIns="0" bIns="0" rtlCol="0" anchor="ctr"/>
+          <a:lstStyle/>
+          <a:p>
+            <a:pPr indent="0" marL="0">
+              <a:buNone/>
+            </a:pPr>
+            <a:r>
+              <a:rPr lang="en-US" sz="1400" i="1" dirty="0">
+                <a:solidFill>
+                  <a:srgbClr val="1E2023"/>
+                </a:solidFill>
+                <a:latin typeface="Cambria" pitchFamily="34" charset="0"/>
+                <a:ea typeface="Cambria" pitchFamily="34" charset="-122"/>
+                <a:cs typeface="Cambria" pitchFamily="34" charset="-120"/>
+              </a:rPr>
+              <a:t>Metro → gallerie</a:t>
+            </a:r>
+            <a:endParaRPr lang="en-US" sz="1400" dirty="0"/>
+          </a:p>
+        </p:txBody>
+      </p:sp>
+      <p:sp>
+        <p:nvSpPr>
+          <p:cNvPr id="16" name="Text 13"/>
+          <p:cNvSpPr txBox="1"/>
+          <p:nvPr/>
+        </p:nvSpPr>
+        <p:spPr>
+          <a:xfrm>
+            <a:off x="2834640" y="4050792"/>
+            <a:ext cx="5623560" cy="384048"/>
+          </a:xfrm>
+          <a:prstGeom prst="rect">
+            <a:avLst/>
+          </a:prstGeom>
+          <a:noFill/>
+          <a:ln/>
+        </p:spPr>
+        <p:txBody>
+          <a:bodyPr wrap="square" lIns="0" tIns="0" rIns="0" bIns="0" rtlCol="0" anchor="ctr"/>
+          <a:lstStyle/>
+          <a:p>
+            <a:pPr indent="0" marL="0">
+              <a:lnSpc>
+                <a:spcPct val="115000"/>
+              </a:lnSpc>
+              <a:spcAft>
+                <a:spcPts val="600"/>
+              </a:spcAft>
+              <a:buNone/>
+            </a:pPr>
+            <a:r>
+              <a:rPr lang="en-US" sz="1150" dirty="0">
+                <a:solidFill>
+                  <a:srgbClr val="5E6266"/>
+                </a:solidFill>
+                <a:latin typeface="Arial" pitchFamily="34" charset="0"/>
+                <a:ea typeface="Arial" pitchFamily="34" charset="-122"/>
+                <a:cs typeface="Arial" pitchFamily="34" charset="-120"/>
+              </a:rPr>
+              <a:t>La metro è moderna: la scena diventa Galleria Subalpina o San Federico, oppure il tram</a:t>
+            </a:r>
+            <a:endParaRPr lang="en-US" sz="1150" dirty="0"/>
+          </a:p>
+        </p:txBody>
+      </p:sp>
+      <p:sp>
+        <p:nvSpPr>
+          <p:cNvPr id="17" name="Shape 14"/>
+          <p:cNvSpPr/>
+          <p:nvPr/>
+        </p:nvSpPr>
+        <p:spPr>
+          <a:xfrm>
+            <a:off x="685800" y="4489704"/>
+            <a:ext cx="7772400" cy="0"/>
+          </a:xfrm>
+          <a:prstGeom prst="line">
+            <a:avLst/>
+          </a:prstGeom>
+          <a:noFill/>
+          <a:ln w="9525">
+            <a:solidFill>
+              <a:srgbClr val="DCDDDC"/>
+            </a:solidFill>
+            <a:prstDash val="solid"/>
+          </a:ln>
+        </p:spPr>
+      </p:sp>
+      <p:sp>
+        <p:nvSpPr>
+          <p:cNvPr id="18" name="Text 15"/>
+          <p:cNvSpPr txBox="1"/>
+          <p:nvPr/>
+        </p:nvSpPr>
+        <p:spPr>
+          <a:xfrm>
+            <a:off x="685800" y="4562856"/>
+            <a:ext cx="2103120" cy="384048"/>
+          </a:xfrm>
+          <a:prstGeom prst="rect">
+            <a:avLst/>
+          </a:prstGeom>
+          <a:noFill/>
+          <a:ln/>
+        </p:spPr>
+        <p:txBody>
+          <a:bodyPr wrap="square" lIns="0" tIns="0" rIns="0" bIns="0" rtlCol="0" anchor="ctr"/>
+          <a:lstStyle/>
+          <a:p>
+            <a:pPr indent="0" marL="0">
+              <a:buNone/>
+            </a:pPr>
+            <a:r>
+              <a:rPr lang="en-US" sz="1400" i="1" dirty="0">
+                <a:solidFill>
+                  <a:srgbClr val="1E2023"/>
+                </a:solidFill>
+                <a:latin typeface="Cambria" pitchFamily="34" charset="0"/>
+                <a:ea typeface="Cambria" pitchFamily="34" charset="-122"/>
+                <a:cs typeface="Cambria" pitchFamily="34" charset="-120"/>
+              </a:rPr>
+              <a:t>Ascensore</a:t>
+            </a:r>
+            <a:endParaRPr lang="en-US" sz="1400" dirty="0"/>
+          </a:p>
+        </p:txBody>
+      </p:sp>
+      <p:sp>
+        <p:nvSpPr>
+          <p:cNvPr id="19" name="Text 16"/>
+          <p:cNvSpPr txBox="1"/>
+          <p:nvPr/>
+        </p:nvSpPr>
+        <p:spPr>
+          <a:xfrm>
+            <a:off x="2834640" y="4562856"/>
+            <a:ext cx="5623560" cy="384048"/>
+          </a:xfrm>
+          <a:prstGeom prst="rect">
+            <a:avLst/>
+          </a:prstGeom>
+          <a:noFill/>
+          <a:ln/>
+        </p:spPr>
+        <p:txBody>
+          <a:bodyPr wrap="square" lIns="0" tIns="0" rIns="0" bIns="0" rtlCol="0" anchor="ctr"/>
+          <a:lstStyle/>
+          <a:p>
+            <a:pPr indent="0" marL="0">
+              <a:lnSpc>
+                <a:spcPct val="115000"/>
+              </a:lnSpc>
+              <a:spcAft>
+                <a:spcPts val="600"/>
+              </a:spcAft>
+              <a:buNone/>
+            </a:pPr>
+            <a:r>
+              <a:rPr lang="en-US" sz="1150" dirty="0">
+                <a:solidFill>
+                  <a:srgbClr val="5E6266"/>
+                </a:solidFill>
+                <a:latin typeface="Arial" pitchFamily="34" charset="0"/>
+                <a:ea typeface="Arial" pitchFamily="34" charset="-122"/>
+                <a:cs typeface="Arial" pitchFamily="34" charset="-120"/>
+              </a:rPr>
+              <a:t>Palazzi liberty di Cit Turin e Crocetta, androni del centro barocco</a:t>
+            </a:r>
+            <a:endParaRPr lang="en-US" sz="1150" dirty="0"/>
+          </a:p>
+        </p:txBody>
+      </p:sp>
+      <p:sp>
+        <p:nvSpPr>
+          <p:cNvPr id="20" name="Shape 17"/>
+          <p:cNvSpPr/>
+          <p:nvPr/>
+        </p:nvSpPr>
+        <p:spPr>
+          <a:xfrm>
+            <a:off x="685800" y="5001768"/>
+            <a:ext cx="7772400" cy="0"/>
+          </a:xfrm>
+          <a:prstGeom prst="line">
+            <a:avLst/>
+          </a:prstGeom>
+          <a:noFill/>
+          <a:ln w="9525">
+            <a:solidFill>
+              <a:srgbClr val="DCDDDC"/>
+            </a:solidFill>
+            <a:prstDash val="solid"/>
+          </a:ln>
+        </p:spPr>
+      </p:sp>
+      <p:sp>
+        <p:nvSpPr>
+          <p:cNvPr id="21" name="Text 18"/>
+          <p:cNvSpPr txBox="1"/>
+          <p:nvPr/>
+        </p:nvSpPr>
+        <p:spPr>
+          <a:xfrm>
+            <a:off x="685800" y="5074920"/>
+            <a:ext cx="2103120" cy="384048"/>
+          </a:xfrm>
+          <a:prstGeom prst="rect">
+            <a:avLst/>
+          </a:prstGeom>
+          <a:noFill/>
+          <a:ln/>
+        </p:spPr>
+        <p:txBody>
+          <a:bodyPr wrap="square" lIns="0" tIns="0" rIns="0" bIns="0" rtlCol="0" anchor="ctr"/>
+          <a:lstStyle/>
+          <a:p>
+            <a:pPr indent="0" marL="0">
+              <a:buNone/>
+            </a:pPr>
+            <a:r>
+              <a:rPr lang="en-US" sz="1400" i="1" dirty="0">
+                <a:solidFill>
+                  <a:srgbClr val="1E2023"/>
+                </a:solidFill>
+                <a:latin typeface="Cambria" pitchFamily="34" charset="0"/>
+                <a:ea typeface="Cambria" pitchFamily="34" charset="-122"/>
+                <a:cs typeface="Cambria" pitchFamily="34" charset="-120"/>
+              </a:rPr>
+              <a:t>Riparo</a:t>
+            </a:r>
+            <a:endParaRPr lang="en-US" sz="1400" dirty="0"/>
+          </a:p>
+        </p:txBody>
+      </p:sp>
+      <p:sp>
+        <p:nvSpPr>
+          <p:cNvPr id="22" name="Text 19"/>
+          <p:cNvSpPr txBox="1"/>
+          <p:nvPr/>
+        </p:nvSpPr>
+        <p:spPr>
+          <a:xfrm>
+            <a:off x="2834640" y="5074920"/>
+            <a:ext cx="5623560" cy="384048"/>
+          </a:xfrm>
+          <a:prstGeom prst="rect">
+            <a:avLst/>
+          </a:prstGeom>
+          <a:noFill/>
+          <a:ln/>
+        </p:spPr>
+        <p:txBody>
+          <a:bodyPr wrap="square" lIns="0" tIns="0" rIns="0" bIns="0" rtlCol="0" anchor="ctr"/>
+          <a:lstStyle/>
+          <a:p>
+            <a:pPr indent="0" marL="0">
+              <a:lnSpc>
+                <a:spcPct val="115000"/>
+              </a:lnSpc>
+              <a:spcAft>
+                <a:spcPts val="600"/>
+              </a:spcAft>
+              <a:buNone/>
+            </a:pPr>
+            <a:r>
+              <a:rPr lang="en-US" sz="1150" dirty="0">
+                <a:solidFill>
+                  <a:srgbClr val="5E6266"/>
+                </a:solidFill>
+                <a:latin typeface="Arial" pitchFamily="34" charset="0"/>
+                <a:ea typeface="Arial" pitchFamily="34" charset="-122"/>
+                <a:cs typeface="Arial" pitchFamily="34" charset="-120"/>
+              </a:rPr>
+              <a:t>I chilometri di portici: Via Po, Via Roma, Piazza San Carlo</a:t>
+            </a:r>
+            <a:endParaRPr lang="en-US" sz="1150" dirty="0"/>
+          </a:p>
+        </p:txBody>
+      </p:sp>
+      <p:sp>
+        <p:nvSpPr>
+          <p:cNvPr id="23" name="Shape 20"/>
+          <p:cNvSpPr/>
+          <p:nvPr/>
+        </p:nvSpPr>
+        <p:spPr>
+          <a:xfrm>
+            <a:off x="685800" y="5513832"/>
+            <a:ext cx="7772400" cy="0"/>
+          </a:xfrm>
+          <a:prstGeom prst="line">
+            <a:avLst/>
+          </a:prstGeom>
+          <a:noFill/>
+          <a:ln w="9525">
+            <a:solidFill>
+              <a:srgbClr val="DCDDDC"/>
+            </a:solidFill>
+            <a:prstDash val="solid"/>
+          </a:ln>
+        </p:spPr>
+      </p:sp>
+      <p:sp>
+        <p:nvSpPr>
+          <p:cNvPr id="24" name="Text 21"/>
+          <p:cNvSpPr txBox="1"/>
+          <p:nvPr/>
+        </p:nvSpPr>
+        <p:spPr>
+          <a:xfrm>
+            <a:off x="685800" y="5586984"/>
+            <a:ext cx="2103120" cy="384048"/>
+          </a:xfrm>
+          <a:prstGeom prst="rect">
+            <a:avLst/>
+          </a:prstGeom>
+          <a:noFill/>
+          <a:ln/>
+        </p:spPr>
+        <p:txBody>
+          <a:bodyPr wrap="square" lIns="0" tIns="0" rIns="0" bIns="0" rtlCol="0" anchor="ctr"/>
+          <a:lstStyle/>
+          <a:p>
+            <a:pPr indent="0" marL="0">
+              <a:buNone/>
+            </a:pPr>
+            <a:r>
+              <a:rPr lang="en-US" sz="1400" i="1" dirty="0">
+                <a:solidFill>
+                  <a:srgbClr val="1E2023"/>
+                </a:solidFill>
+                <a:latin typeface="Cambria" pitchFamily="34" charset="0"/>
+                <a:ea typeface="Cambria" pitchFamily="34" charset="-122"/>
+                <a:cs typeface="Cambria" pitchFamily="34" charset="-120"/>
+              </a:rPr>
+              <a:t>Passeggiata</a:t>
+            </a:r>
+            <a:endParaRPr lang="en-US" sz="1400" dirty="0"/>
+          </a:p>
+        </p:txBody>
+      </p:sp>
+      <p:sp>
+        <p:nvSpPr>
+          <p:cNvPr id="25" name="Text 22"/>
+          <p:cNvSpPr txBox="1"/>
+          <p:nvPr/>
+        </p:nvSpPr>
+        <p:spPr>
+          <a:xfrm>
+            <a:off x="2834640" y="5586984"/>
+            <a:ext cx="5623560" cy="384048"/>
+          </a:xfrm>
+          <a:prstGeom prst="rect">
+            <a:avLst/>
+          </a:prstGeom>
+          <a:noFill/>
+          <a:ln/>
+        </p:spPr>
+        <p:txBody>
+          <a:bodyPr wrap="square" lIns="0" tIns="0" rIns="0" bIns="0" rtlCol="0" anchor="ctr"/>
+          <a:lstStyle/>
+          <a:p>
+            <a:pPr indent="0" marL="0">
+              <a:lnSpc>
+                <a:spcPct val="115000"/>
+              </a:lnSpc>
+              <a:spcAft>
+                <a:spcPts val="600"/>
+              </a:spcAft>
+              <a:buNone/>
+            </a:pPr>
+            <a:r>
+              <a:rPr lang="en-US" sz="1150" dirty="0">
+                <a:solidFill>
+                  <a:srgbClr val="5E6266"/>
+                </a:solidFill>
+                <a:latin typeface="Arial" pitchFamily="34" charset="0"/>
+                <a:ea typeface="Arial" pitchFamily="34" charset="-122"/>
+                <a:cs typeface="Arial" pitchFamily="34" charset="-120"/>
+              </a:rPr>
+              <a:t>Parco del Valentino e Murazzi del Po nella nebbia</a:t>
+            </a:r>
+            <a:endParaRPr lang="en-US" sz="1150" dirty="0"/>
+          </a:p>
+        </p:txBody>
+      </p:sp>
+      <p:sp>
+        <p:nvSpPr>
+          <p:cNvPr id="26" name="Text 23"/>
+          <p:cNvSpPr txBox="1"/>
+          <p:nvPr/>
+        </p:nvSpPr>
+        <p:spPr>
+          <a:xfrm>
+            <a:off x="685800" y="6217920"/>
+            <a:ext cx="7772400" cy="274320"/>
+          </a:xfrm>
+          <a:prstGeom prst="rect">
+            <a:avLst/>
+          </a:prstGeom>
+          <a:noFill/>
+          <a:ln/>
+        </p:spPr>
+        <p:txBody>
+          <a:bodyPr wrap="square" lIns="0" tIns="0" rIns="0" bIns="0" rtlCol="0" anchor="t"/>
+          <a:lstStyle/>
+          <a:p>
+            <a:pPr indent="0" marL="0">
+              <a:lnSpc>
+                <a:spcPct val="115000"/>
+              </a:lnSpc>
+              <a:spcAft>
+                <a:spcPts val="600"/>
+              </a:spcAft>
+              <a:buNone/>
+            </a:pPr>
+            <a:r>
+              <a:rPr lang="en-US" sz="1000" dirty="0">
+                <a:solidFill>
+                  <a:srgbClr val="8A8D90"/>
+                </a:solidFill>
+                <a:latin typeface="Arial" pitchFamily="34" charset="0"/>
+                <a:ea typeface="Arial" pitchFamily="34" charset="-122"/>
+                <a:cs typeface="Arial" pitchFamily="34" charset="-120"/>
+              </a:rPr>
+              <a:t>Permessi: Comune di Torino, con il supporto di Film Commission Torino Piemonte. Location da verificare in sopralluogo.</a:t>
+            </a:r>
+            <a:endParaRPr lang="en-US" sz="1000" dirty="0"/>
+          </a:p>
+        </p:txBody>
+      </p:sp>
+    </p:spTree>
+  </p:cSld>
+  <p:clrMapOvr>
+    <a:masterClrMapping/>
+  </p:clrMapOvr>
+</p:sld>
+</file>
+
+<file path=ppt/slides/slide15.xml><?xml version="1.0" encoding="utf-8"?>
+<p:sld xmlns:a="http://schemas.openxmlformats.org/drawingml/2006/main" xmlns:r="http://schemas.openxmlformats.org/officeDocument/2006/relationships" xmlns:p="http://schemas.openxmlformats.org/presentationml/2006/main">
+  <p:cSld name="Slide 15">
+    <p:bg>
+      <p:bgPr>
+        <a:solidFill>
           <a:srgbClr val="F2F2F0"/>
         </a:solidFill>
       </p:bgPr>
@@ -5536,7 +6663,7 @@
                 <a:ea typeface="Arial" pitchFamily="34" charset="-122"/>
                 <a:cs typeface="Arial" pitchFamily="34" charset="-120"/>
               </a:rPr>
-              <a:t>09 — PRODUZIONE</a:t>
+              <a:t>08 — ALTRE ALTERNATIVE</a:t>
             </a:r>
             <a:endParaRPr lang="en-US" sz="1000" dirty="0"/>
           </a:p>
@@ -5551,7 +6678,7 @@
         <p:spPr>
           <a:xfrm>
             <a:off x="685800" y="868680"/>
-            <a:ext cx="7315200" cy="731520"/>
+            <a:ext cx="10058400" cy="731520"/>
           </a:xfrm>
           <a:prstGeom prst="rect">
             <a:avLst/>
@@ -5575,7 +6702,7 @@
                 <a:ea typeface="Cambria" pitchFamily="34" charset="-122"/>
                 <a:cs typeface="Cambria" pitchFamily="34" charset="-120"/>
               </a:rPr>
-              <a:t>Come la realizziamo</a:t>
+              <a:t>Se non Parigi, dove</a:t>
             </a:r>
             <a:endParaRPr lang="en-US" sz="3400" dirty="0"/>
           </a:p>
@@ -5589,8 +6716,240 @@
         </p:nvSpPr>
         <p:spPr>
           <a:xfrm>
-            <a:off x="685800" y="1783080"/>
-            <a:ext cx="5257800" cy="1783080"/>
+            <a:off x="685800" y="1828800"/>
+            <a:ext cx="2560320" cy="4206240"/>
+          </a:xfrm>
+          <a:prstGeom prst="rect">
+            <a:avLst/>
+          </a:prstGeom>
+          <a:solidFill>
+            <a:srgbClr val="1E2023"/>
+          </a:solidFill>
+          <a:ln w="9525">
+            <a:solidFill>
+              <a:srgbClr val="1E2023"/>
+            </a:solidFill>
+            <a:prstDash val="solid"/>
+          </a:ln>
+        </p:spPr>
+      </p:sp>
+      <p:sp>
+        <p:nvSpPr>
+          <p:cNvPr id="5" name="Text 3"/>
+          <p:cNvSpPr txBox="1"/>
+          <p:nvPr/>
+        </p:nvSpPr>
+        <p:spPr>
+          <a:xfrm>
+            <a:off x="914400" y="2103120"/>
+            <a:ext cx="2103120" cy="502920"/>
+          </a:xfrm>
+          <a:prstGeom prst="rect">
+            <a:avLst/>
+          </a:prstGeom>
+          <a:noFill/>
+          <a:ln/>
+        </p:spPr>
+        <p:txBody>
+          <a:bodyPr wrap="square" lIns="0" tIns="0" rIns="0" bIns="0" rtlCol="0" anchor="ctr"/>
+          <a:lstStyle/>
+          <a:p>
+            <a:pPr indent="0" marL="0">
+              <a:buNone/>
+            </a:pPr>
+            <a:r>
+              <a:rPr lang="en-US" sz="2600" i="1" dirty="0">
+                <a:solidFill>
+                  <a:srgbClr val="FFFFFF"/>
+                </a:solidFill>
+                <a:latin typeface="Cambria" pitchFamily="34" charset="0"/>
+                <a:ea typeface="Cambria" pitchFamily="34" charset="-122"/>
+                <a:cs typeface="Cambria" pitchFamily="34" charset="-120"/>
+              </a:rPr>
+              <a:t>Torino</a:t>
+            </a:r>
+            <a:endParaRPr lang="en-US" sz="2600" dirty="0"/>
+          </a:p>
+        </p:txBody>
+      </p:sp>
+      <p:sp>
+        <p:nvSpPr>
+          <p:cNvPr id="6" name="Text 4"/>
+          <p:cNvSpPr txBox="1"/>
+          <p:nvPr/>
+        </p:nvSpPr>
+        <p:spPr>
+          <a:xfrm>
+            <a:off x="914400" y="2651760"/>
+            <a:ext cx="2103120" cy="274320"/>
+          </a:xfrm>
+          <a:prstGeom prst="rect">
+            <a:avLst/>
+          </a:prstGeom>
+          <a:noFill/>
+          <a:ln/>
+        </p:spPr>
+        <p:txBody>
+          <a:bodyPr wrap="square" lIns="0" tIns="0" rIns="0" bIns="0" rtlCol="0" anchor="ctr"/>
+          <a:lstStyle/>
+          <a:p>
+            <a:pPr indent="0" marL="0">
+              <a:buNone/>
+            </a:pPr>
+            <a:r>
+              <a:rPr lang="en-US" sz="900" spc="300" kern="0" dirty="0">
+                <a:solidFill>
+                  <a:srgbClr val="A8875A"/>
+                </a:solidFill>
+                <a:latin typeface="Arial" pitchFamily="34" charset="0"/>
+                <a:ea typeface="Arial" pitchFamily="34" charset="-122"/>
+                <a:cs typeface="Arial" pitchFamily="34" charset="-120"/>
+              </a:rPr>
+              <a:t>CONSIGLIATA</a:t>
+            </a:r>
+            <a:endParaRPr lang="en-US" sz="900" dirty="0"/>
+          </a:p>
+        </p:txBody>
+      </p:sp>
+      <p:sp>
+        <p:nvSpPr>
+          <p:cNvPr id="7" name="Text 5"/>
+          <p:cNvSpPr txBox="1"/>
+          <p:nvPr/>
+        </p:nvSpPr>
+        <p:spPr>
+          <a:xfrm>
+            <a:off x="914400" y="3063240"/>
+            <a:ext cx="2103120" cy="1920240"/>
+          </a:xfrm>
+          <a:prstGeom prst="rect">
+            <a:avLst/>
+          </a:prstGeom>
+          <a:noFill/>
+          <a:ln/>
+        </p:spPr>
+        <p:txBody>
+          <a:bodyPr wrap="square" lIns="0" tIns="0" rIns="0" bIns="0" rtlCol="0" anchor="t"/>
+          <a:lstStyle/>
+          <a:p>
+            <a:pPr indent="0" marL="0">
+              <a:lnSpc>
+                <a:spcPct val="115000"/>
+              </a:lnSpc>
+              <a:spcAft>
+                <a:spcPts val="600"/>
+              </a:spcAft>
+              <a:buNone/>
+            </a:pPr>
+            <a:r>
+              <a:rPr lang="en-US" sz="1200" dirty="0">
+                <a:solidFill>
+                  <a:srgbClr val="DCDDDC"/>
+                </a:solidFill>
+                <a:latin typeface="Arial" pitchFamily="34" charset="0"/>
+                <a:ea typeface="Arial" pitchFamily="34" charset="-122"/>
+                <a:cs typeface="Arial" pitchFamily="34" charset="-120"/>
+              </a:rPr>
+              <a:t>Portici, caffè storici, nebbia sul Po, palazzi liberty. È la più vicina all’immaginario di Parigi con costi italiani.</a:t>
+            </a:r>
+            <a:endParaRPr lang="en-US" sz="1200" dirty="0"/>
+          </a:p>
+        </p:txBody>
+      </p:sp>
+      <p:sp>
+        <p:nvSpPr>
+          <p:cNvPr id="8" name="Text 6"/>
+          <p:cNvSpPr txBox="1"/>
+          <p:nvPr/>
+        </p:nvSpPr>
+        <p:spPr>
+          <a:xfrm>
+            <a:off x="914400" y="5029200"/>
+            <a:ext cx="2103120" cy="274320"/>
+          </a:xfrm>
+          <a:prstGeom prst="rect">
+            <a:avLst/>
+          </a:prstGeom>
+          <a:noFill/>
+          <a:ln/>
+        </p:spPr>
+        <p:txBody>
+          <a:bodyPr wrap="square" lIns="0" tIns="0" rIns="0" bIns="0" rtlCol="0" anchor="ctr"/>
+          <a:lstStyle/>
+          <a:p>
+            <a:pPr indent="0" marL="0">
+              <a:buNone/>
+            </a:pPr>
+            <a:r>
+              <a:rPr lang="en-US" sz="1000" spc="400" kern="0" dirty="0">
+                <a:solidFill>
+                  <a:srgbClr val="A9ACAE"/>
+                </a:solidFill>
+                <a:latin typeface="Arial" pitchFamily="34" charset="0"/>
+                <a:ea typeface="Arial" pitchFamily="34" charset="-122"/>
+                <a:cs typeface="Arial" pitchFamily="34" charset="-120"/>
+              </a:rPr>
+              <a:t>CONTRO</a:t>
+            </a:r>
+            <a:endParaRPr lang="en-US" sz="1000" dirty="0"/>
+          </a:p>
+        </p:txBody>
+      </p:sp>
+      <p:sp>
+        <p:nvSpPr>
+          <p:cNvPr id="9" name="Text 7"/>
+          <p:cNvSpPr txBox="1"/>
+          <p:nvPr/>
+        </p:nvSpPr>
+        <p:spPr>
+          <a:xfrm>
+            <a:off x="914400" y="5303520"/>
+            <a:ext cx="2103120" cy="640080"/>
+          </a:xfrm>
+          <a:prstGeom prst="rect">
+            <a:avLst/>
+          </a:prstGeom>
+          <a:noFill/>
+          <a:ln/>
+        </p:spPr>
+        <p:txBody>
+          <a:bodyPr wrap="square" lIns="0" tIns="0" rIns="0" bIns="0" rtlCol="0" anchor="t"/>
+          <a:lstStyle/>
+          <a:p>
+            <a:pPr indent="0" marL="0">
+              <a:lnSpc>
+                <a:spcPct val="115000"/>
+              </a:lnSpc>
+              <a:spcAft>
+                <a:spcPts val="600"/>
+              </a:spcAft>
+              <a:buNone/>
+            </a:pPr>
+            <a:r>
+              <a:rPr lang="en-US" sz="1150" dirty="0">
+                <a:solidFill>
+                  <a:srgbClr val="DCDDDC"/>
+                </a:solidFill>
+                <a:latin typeface="Arial" pitchFamily="34" charset="0"/>
+                <a:ea typeface="Arial" pitchFamily="34" charset="-122"/>
+                <a:cs typeface="Arial" pitchFamily="34" charset="-120"/>
+              </a:rPr>
+              <a:t>La metro non ha fascino: la scena va sostituita.</a:t>
+            </a:r>
+            <a:endParaRPr lang="en-US" sz="1150" dirty="0"/>
+          </a:p>
+        </p:txBody>
+      </p:sp>
+      <p:sp>
+        <p:nvSpPr>
+          <p:cNvPr id="10" name="Shape 8"/>
+          <p:cNvSpPr/>
+          <p:nvPr/>
+        </p:nvSpPr>
+        <p:spPr>
+          <a:xfrm>
+            <a:off x="3429000" y="1828800"/>
+            <a:ext cx="2560320" cy="4206240"/>
           </a:xfrm>
           <a:prstGeom prst="rect">
             <a:avLst/>
@@ -5608,14 +6967,14 @@
       </p:sp>
       <p:sp>
         <p:nvSpPr>
-          <p:cNvPr id="5" name="Text 3"/>
-          <p:cNvSpPr txBox="1"/>
-          <p:nvPr/>
-        </p:nvSpPr>
-        <p:spPr>
-          <a:xfrm>
-            <a:off x="960120" y="2011680"/>
-            <a:ext cx="4709160" cy="365760"/>
+          <p:cNvPr id="11" name="Text 9"/>
+          <p:cNvSpPr txBox="1"/>
+          <p:nvPr/>
+        </p:nvSpPr>
+        <p:spPr>
+          <a:xfrm>
+            <a:off x="3657600" y="2103120"/>
+            <a:ext cx="2103120" cy="502920"/>
           </a:xfrm>
           <a:prstGeom prst="rect">
             <a:avLst/>
@@ -5631,7 +6990,7 @@
               <a:buNone/>
             </a:pPr>
             <a:r>
-              <a:rPr lang="en-US" sz="1800" i="1" dirty="0">
+              <a:rPr lang="en-US" sz="2600" i="1" dirty="0">
                 <a:solidFill>
                   <a:srgbClr val="1E2023"/>
                 </a:solidFill>
@@ -5639,22 +6998,61 @@
                 <a:ea typeface="Cambria" pitchFamily="34" charset="-122"/>
                 <a:cs typeface="Cambria" pitchFamily="34" charset="-120"/>
               </a:rPr>
-              <a:t>Quando</a:t>
-            </a:r>
-            <a:endParaRPr lang="en-US" sz="1800" dirty="0"/>
-          </a:p>
-        </p:txBody>
-      </p:sp>
-      <p:sp>
-        <p:nvSpPr>
-          <p:cNvPr id="6" name="Text 4"/>
-          <p:cNvSpPr txBox="1"/>
-          <p:nvPr/>
-        </p:nvSpPr>
-        <p:spPr>
-          <a:xfrm>
-            <a:off x="960120" y="2468880"/>
-            <a:ext cx="4709160" cy="1005840"/>
+              <a:t>Lione</a:t>
+            </a:r>
+            <a:endParaRPr lang="en-US" sz="2600" dirty="0"/>
+          </a:p>
+        </p:txBody>
+      </p:sp>
+      <p:sp>
+        <p:nvSpPr>
+          <p:cNvPr id="12" name="Text 10"/>
+          <p:cNvSpPr txBox="1"/>
+          <p:nvPr/>
+        </p:nvSpPr>
+        <p:spPr>
+          <a:xfrm>
+            <a:off x="3657600" y="2651760"/>
+            <a:ext cx="2103120" cy="274320"/>
+          </a:xfrm>
+          <a:prstGeom prst="rect">
+            <a:avLst/>
+          </a:prstGeom>
+          <a:noFill/>
+          <a:ln/>
+        </p:spPr>
+        <p:txBody>
+          <a:bodyPr wrap="square" lIns="0" tIns="0" rIns="0" bIns="0" rtlCol="0" anchor="ctr"/>
+          <a:lstStyle/>
+          <a:p>
+            <a:pPr indent="0" marL="0">
+              <a:buNone/>
+            </a:pPr>
+            <a:r>
+              <a:rPr lang="en-US" sz="900" spc="300" kern="0" dirty="0">
+                <a:solidFill>
+                  <a:srgbClr val="A8875A"/>
+                </a:solidFill>
+                <a:latin typeface="Arial" pitchFamily="34" charset="0"/>
+                <a:ea typeface="Arial" pitchFamily="34" charset="-122"/>
+                <a:cs typeface="Arial" pitchFamily="34" charset="-120"/>
+              </a:rPr>
+              <a:t>RESTA IN FRANCIA</a:t>
+            </a:r>
+            <a:endParaRPr lang="en-US" sz="900" dirty="0"/>
+          </a:p>
+        </p:txBody>
+      </p:sp>
+      <p:sp>
+        <p:nvSpPr>
+          <p:cNvPr id="13" name="Text 11"/>
+          <p:cNvSpPr txBox="1"/>
+          <p:nvPr/>
+        </p:nvSpPr>
+        <p:spPr>
+          <a:xfrm>
+            <a:off x="3657600" y="3063240"/>
+            <a:ext cx="2103120" cy="1920240"/>
           </a:xfrm>
           <a:prstGeom prst="rect">
             <a:avLst/>
@@ -5676,7 +7074,7 @@
               <a:buNone/>
             </a:pPr>
             <a:r>
-              <a:rPr lang="en-US" sz="1250" dirty="0">
+              <a:rPr lang="en-US" sz="1200" dirty="0">
                 <a:solidFill>
                   <a:srgbClr val="5E6266"/>
                 </a:solidFill>
@@ -5684,22 +7082,106 @@
                 <a:ea typeface="Arial" pitchFamily="34" charset="-122"/>
                 <a:cs typeface="Arial" pitchFamily="34" charset="-120"/>
               </a:rPr>
-              <a:t>Da metà novembre a inizio dicembre: foglie ancora a terra, luce bassa, pioggia e nebbia al mattino. 2 giorni di scatto più 1 di riserva meteo.</a:t>
-            </a:r>
-            <a:endParaRPr lang="en-US" sz="1250" dirty="0"/>
-          </a:p>
-        </p:txBody>
-      </p:sp>
-      <p:sp>
-        <p:nvSpPr>
-          <p:cNvPr id="7" name="Shape 5"/>
+              <a:t>Presqu’île ottocentesca, traboules, nebbia sulla Saona, funicolare e metro. Atmosfera francese, costi inferiori a Parigi.</a:t>
+            </a:r>
+            <a:endParaRPr lang="en-US" sz="1200" dirty="0"/>
+          </a:p>
+        </p:txBody>
+      </p:sp>
+      <p:sp>
+        <p:nvSpPr>
+          <p:cNvPr id="14" name="Text 12"/>
+          <p:cNvSpPr txBox="1"/>
+          <p:nvPr/>
+        </p:nvSpPr>
+        <p:spPr>
+          <a:xfrm>
+            <a:off x="3657600" y="5029200"/>
+            <a:ext cx="2103120" cy="274320"/>
+          </a:xfrm>
+          <a:prstGeom prst="rect">
+            <a:avLst/>
+          </a:prstGeom>
+          <a:noFill/>
+          <a:ln/>
+        </p:spPr>
+        <p:txBody>
+          <a:bodyPr wrap="square" lIns="0" tIns="0" rIns="0" bIns="0" rtlCol="0" anchor="ctr"/>
+          <a:lstStyle/>
+          <a:p>
+            <a:pPr indent="0" marL="0">
+              <a:buNone/>
+            </a:pPr>
+            <a:r>
+              <a:rPr lang="en-US" sz="1000" spc="400" kern="0" dirty="0">
+                <a:solidFill>
+                  <a:srgbClr val="8A8D90"/>
+                </a:solidFill>
+                <a:latin typeface="Arial" pitchFamily="34" charset="0"/>
+                <a:ea typeface="Arial" pitchFamily="34" charset="-122"/>
+                <a:cs typeface="Arial" pitchFamily="34" charset="-120"/>
+              </a:rPr>
+              <a:t>CONTRO</a:t>
+            </a:r>
+            <a:endParaRPr lang="en-US" sz="1000" dirty="0"/>
+          </a:p>
+        </p:txBody>
+      </p:sp>
+      <p:sp>
+        <p:nvSpPr>
+          <p:cNvPr id="15" name="Text 13"/>
+          <p:cNvSpPr txBox="1"/>
+          <p:nvPr/>
+        </p:nvSpPr>
+        <p:spPr>
+          <a:xfrm>
+            <a:off x="3657600" y="5303520"/>
+            <a:ext cx="2103120" cy="640080"/>
+          </a:xfrm>
+          <a:prstGeom prst="rect">
+            <a:avLst/>
+          </a:prstGeom>
+          <a:noFill/>
+          <a:ln/>
+        </p:spPr>
+        <p:txBody>
+          <a:bodyPr wrap="square" lIns="0" tIns="0" rIns="0" bIns="0" rtlCol="0" anchor="t"/>
+          <a:lstStyle/>
+          <a:p>
+            <a:pPr indent="0" marL="0">
+              <a:lnSpc>
+                <a:spcPct val="115000"/>
+              </a:lnSpc>
+              <a:spcAft>
+                <a:spcPts val="600"/>
+              </a:spcAft>
+              <a:buNone/>
+            </a:pPr>
+            <a:r>
+              <a:rPr lang="en-US" sz="1150" dirty="0">
+                <a:solidFill>
+                  <a:srgbClr val="5E6266"/>
+                </a:solidFill>
+                <a:latin typeface="Arial" pitchFamily="34" charset="0"/>
+                <a:ea typeface="Arial" pitchFamily="34" charset="-122"/>
+                <a:cs typeface="Arial" pitchFamily="34" charset="-120"/>
+              </a:rPr>
+              <a:t>È comunque una produzione all’estero.</a:t>
+            </a:r>
+            <a:endParaRPr lang="en-US" sz="1150" dirty="0"/>
+          </a:p>
+        </p:txBody>
+      </p:sp>
+      <p:sp>
+        <p:nvSpPr>
+          <p:cNvPr id="16" name="Shape 14"/>
           <p:cNvSpPr/>
           <p:nvPr/>
         </p:nvSpPr>
         <p:spPr>
           <a:xfrm>
-            <a:off x="6217920" y="1783080"/>
-            <a:ext cx="5257800" cy="1783080"/>
+            <a:off x="6172200" y="1828800"/>
+            <a:ext cx="2560320" cy="4206240"/>
           </a:xfrm>
           <a:prstGeom prst="rect">
             <a:avLst/>
@@ -5717,14 +7199,14 @@
       </p:sp>
       <p:sp>
         <p:nvSpPr>
-          <p:cNvPr id="8" name="Text 6"/>
-          <p:cNvSpPr txBox="1"/>
-          <p:nvPr/>
-        </p:nvSpPr>
-        <p:spPr>
-          <a:xfrm>
-            <a:off x="6492240" y="2011680"/>
-            <a:ext cx="4709160" cy="365760"/>
+          <p:cNvPr id="17" name="Text 15"/>
+          <p:cNvSpPr txBox="1"/>
+          <p:nvPr/>
+        </p:nvSpPr>
+        <p:spPr>
+          <a:xfrm>
+            <a:off x="6400800" y="2103120"/>
+            <a:ext cx="2103120" cy="502920"/>
           </a:xfrm>
           <a:prstGeom prst="rect">
             <a:avLst/>
@@ -5740,7 +7222,7 @@
               <a:buNone/>
             </a:pPr>
             <a:r>
-              <a:rPr lang="en-US" sz="1800" i="1" dirty="0">
+              <a:rPr lang="en-US" sz="2600" i="1" dirty="0">
                 <a:solidFill>
                   <a:srgbClr val="1E2023"/>
                 </a:solidFill>
@@ -5748,22 +7230,61 @@
                 <a:ea typeface="Cambria" pitchFamily="34" charset="-122"/>
                 <a:cs typeface="Cambria" pitchFamily="34" charset="-120"/>
               </a:rPr>
-              <a:t>Troupe leggera</a:t>
-            </a:r>
-            <a:endParaRPr lang="en-US" sz="1800" dirty="0"/>
-          </a:p>
-        </p:txBody>
-      </p:sp>
-      <p:sp>
-        <p:nvSpPr>
-          <p:cNvPr id="9" name="Text 7"/>
-          <p:cNvSpPr txBox="1"/>
-          <p:nvPr/>
-        </p:nvSpPr>
-        <p:spPr>
-          <a:xfrm>
-            <a:off x="6492240" y="2468880"/>
-            <a:ext cx="4709160" cy="1005840"/>
+              <a:t>Trieste</a:t>
+            </a:r>
+            <a:endParaRPr lang="en-US" sz="2600" dirty="0"/>
+          </a:p>
+        </p:txBody>
+      </p:sp>
+      <p:sp>
+        <p:nvSpPr>
+          <p:cNvPr id="18" name="Text 16"/>
+          <p:cNvSpPr txBox="1"/>
+          <p:nvPr/>
+        </p:nvSpPr>
+        <p:spPr>
+          <a:xfrm>
+            <a:off x="6400800" y="2651760"/>
+            <a:ext cx="2103120" cy="274320"/>
+          </a:xfrm>
+          <a:prstGeom prst="rect">
+            <a:avLst/>
+          </a:prstGeom>
+          <a:noFill/>
+          <a:ln/>
+        </p:spPr>
+        <p:txBody>
+          <a:bodyPr wrap="square" lIns="0" tIns="0" rIns="0" bIns="0" rtlCol="0" anchor="ctr"/>
+          <a:lstStyle/>
+          <a:p>
+            <a:pPr indent="0" marL="0">
+              <a:buNone/>
+            </a:pPr>
+            <a:r>
+              <a:rPr lang="en-US" sz="900" spc="300" kern="0" dirty="0">
+                <a:solidFill>
+                  <a:srgbClr val="A8875A"/>
+                </a:solidFill>
+                <a:latin typeface="Arial" pitchFamily="34" charset="0"/>
+                <a:ea typeface="Arial" pitchFamily="34" charset="-122"/>
+                <a:cs typeface="Arial" pitchFamily="34" charset="-120"/>
+              </a:rPr>
+              <a:t>PIÙ LETTERARIA</a:t>
+            </a:r>
+            <a:endParaRPr lang="en-US" sz="900" dirty="0"/>
+          </a:p>
+        </p:txBody>
+      </p:sp>
+      <p:sp>
+        <p:nvSpPr>
+          <p:cNvPr id="19" name="Text 17"/>
+          <p:cNvSpPr txBox="1"/>
+          <p:nvPr/>
+        </p:nvSpPr>
+        <p:spPr>
+          <a:xfrm>
+            <a:off x="6400800" y="3063240"/>
+            <a:ext cx="2103120" cy="1920240"/>
           </a:xfrm>
           <a:prstGeom prst="rect">
             <a:avLst/>
@@ -5785,7 +7306,7 @@
               <a:buNone/>
             </a:pPr>
             <a:r>
-              <a:rPr lang="en-US" sz="1250" dirty="0">
+              <a:rPr lang="en-US" sz="1200" dirty="0">
                 <a:solidFill>
                   <a:srgbClr val="5E6266"/>
                 </a:solidFill>
@@ -5793,22 +7314,106 @@
                 <a:ea typeface="Arial" pitchFamily="34" charset="-122"/>
                 <a:cs typeface="Arial" pitchFamily="34" charset="-120"/>
               </a:rPr>
-              <a:t>Fotografo con teleobiettivo, videomaker, stylist, hair &amp; make-up, producer locale. Una modella, qualche comparsa per strada e in metro.</a:t>
-            </a:r>
-            <a:endParaRPr lang="en-US" sz="1250" dirty="0"/>
-          </a:p>
-        </p:txBody>
-      </p:sp>
-      <p:sp>
-        <p:nvSpPr>
-          <p:cNvPr id="10" name="Shape 8"/>
+              <a:t>Caffè storici, palazzi neoclassici e asburgici, luce grigia d’inverno. Città raccolta, facile da girare.</a:t>
+            </a:r>
+            <a:endParaRPr lang="en-US" sz="1200" dirty="0"/>
+          </a:p>
+        </p:txBody>
+      </p:sp>
+      <p:sp>
+        <p:nvSpPr>
+          <p:cNvPr id="20" name="Text 18"/>
+          <p:cNvSpPr txBox="1"/>
+          <p:nvPr/>
+        </p:nvSpPr>
+        <p:spPr>
+          <a:xfrm>
+            <a:off x="6400800" y="5029200"/>
+            <a:ext cx="2103120" cy="274320"/>
+          </a:xfrm>
+          <a:prstGeom prst="rect">
+            <a:avLst/>
+          </a:prstGeom>
+          <a:noFill/>
+          <a:ln/>
+        </p:spPr>
+        <p:txBody>
+          <a:bodyPr wrap="square" lIns="0" tIns="0" rIns="0" bIns="0" rtlCol="0" anchor="ctr"/>
+          <a:lstStyle/>
+          <a:p>
+            <a:pPr indent="0" marL="0">
+              <a:buNone/>
+            </a:pPr>
+            <a:r>
+              <a:rPr lang="en-US" sz="1000" spc="400" kern="0" dirty="0">
+                <a:solidFill>
+                  <a:srgbClr val="8A8D90"/>
+                </a:solidFill>
+                <a:latin typeface="Arial" pitchFamily="34" charset="0"/>
+                <a:ea typeface="Arial" pitchFamily="34" charset="-122"/>
+                <a:cs typeface="Arial" pitchFamily="34" charset="-120"/>
+              </a:rPr>
+              <a:t>CONTRO</a:t>
+            </a:r>
+            <a:endParaRPr lang="en-US" sz="1000" dirty="0"/>
+          </a:p>
+        </p:txBody>
+      </p:sp>
+      <p:sp>
+        <p:nvSpPr>
+          <p:cNvPr id="21" name="Text 19"/>
+          <p:cNvSpPr txBox="1"/>
+          <p:nvPr/>
+        </p:nvSpPr>
+        <p:spPr>
+          <a:xfrm>
+            <a:off x="6400800" y="5303520"/>
+            <a:ext cx="2103120" cy="640080"/>
+          </a:xfrm>
+          <a:prstGeom prst="rect">
+            <a:avLst/>
+          </a:prstGeom>
+          <a:noFill/>
+          <a:ln/>
+        </p:spPr>
+        <p:txBody>
+          <a:bodyPr wrap="square" lIns="0" tIns="0" rIns="0" bIns="0" rtlCol="0" anchor="t"/>
+          <a:lstStyle/>
+          <a:p>
+            <a:pPr indent="0" marL="0">
+              <a:lnSpc>
+                <a:spcPct val="115000"/>
+              </a:lnSpc>
+              <a:spcAft>
+                <a:spcPts val="600"/>
+              </a:spcAft>
+              <a:buNone/>
+            </a:pPr>
+            <a:r>
+              <a:rPr lang="en-US" sz="1150" dirty="0">
+                <a:solidFill>
+                  <a:srgbClr val="5E6266"/>
+                </a:solidFill>
+                <a:latin typeface="Arial" pitchFamily="34" charset="0"/>
+                <a:ea typeface="Arial" pitchFamily="34" charset="-122"/>
+                <a:cs typeface="Arial" pitchFamily="34" charset="-120"/>
+              </a:rPr>
+              <a:t>Più mare e bora che nebbia e foglie.</a:t>
+            </a:r>
+            <a:endParaRPr lang="en-US" sz="1150" dirty="0"/>
+          </a:p>
+        </p:txBody>
+      </p:sp>
+      <p:sp>
+        <p:nvSpPr>
+          <p:cNvPr id="22" name="Shape 20"/>
           <p:cNvSpPr/>
           <p:nvPr/>
         </p:nvSpPr>
         <p:spPr>
           <a:xfrm>
-            <a:off x="685800" y="3794760"/>
-            <a:ext cx="5257800" cy="1783080"/>
+            <a:off x="8915400" y="1828800"/>
+            <a:ext cx="2560320" cy="4206240"/>
           </a:xfrm>
           <a:prstGeom prst="rect">
             <a:avLst/>
@@ -5826,14 +7431,14 @@
       </p:sp>
       <p:sp>
         <p:nvSpPr>
-          <p:cNvPr id="11" name="Text 9"/>
-          <p:cNvSpPr txBox="1"/>
-          <p:nvPr/>
-        </p:nvSpPr>
-        <p:spPr>
-          <a:xfrm>
-            <a:off x="960120" y="4023360"/>
-            <a:ext cx="4709160" cy="365760"/>
+          <p:cNvPr id="23" name="Text 21"/>
+          <p:cNvSpPr txBox="1"/>
+          <p:nvPr/>
+        </p:nvSpPr>
+        <p:spPr>
+          <a:xfrm>
+            <a:off x="9144000" y="2103120"/>
+            <a:ext cx="2103120" cy="502920"/>
           </a:xfrm>
           <a:prstGeom prst="rect">
             <a:avLst/>
@@ -5849,7 +7454,7 @@
               <a:buNone/>
             </a:pPr>
             <a:r>
-              <a:rPr lang="en-US" sz="1800" i="1" dirty="0">
+              <a:rPr lang="en-US" sz="2600" i="1" dirty="0">
                 <a:solidFill>
                   <a:srgbClr val="1E2023"/>
                 </a:solidFill>
@@ -5857,22 +7462,61 @@
                 <a:ea typeface="Cambria" pitchFamily="34" charset="-122"/>
                 <a:cs typeface="Cambria" pitchFamily="34" charset="-120"/>
               </a:rPr>
-              <a:t>Permessi</a:t>
-            </a:r>
-            <a:endParaRPr lang="en-US" sz="1800" dirty="0"/>
-          </a:p>
-        </p:txBody>
-      </p:sp>
-      <p:sp>
-        <p:nvSpPr>
-          <p:cNvPr id="12" name="Text 10"/>
-          <p:cNvSpPr txBox="1"/>
-          <p:nvPr/>
-        </p:nvSpPr>
-        <p:spPr>
-          <a:xfrm>
-            <a:off x="960120" y="4480560"/>
-            <a:ext cx="4709160" cy="1005840"/>
+              <a:t>Milano</a:t>
+            </a:r>
+            <a:endParaRPr lang="en-US" sz="2600" dirty="0"/>
+          </a:p>
+        </p:txBody>
+      </p:sp>
+      <p:sp>
+        <p:nvSpPr>
+          <p:cNvPr id="24" name="Text 22"/>
+          <p:cNvSpPr txBox="1"/>
+          <p:nvPr/>
+        </p:nvSpPr>
+        <p:spPr>
+          <a:xfrm>
+            <a:off x="9144000" y="2651760"/>
+            <a:ext cx="2103120" cy="274320"/>
+          </a:xfrm>
+          <a:prstGeom prst="rect">
+            <a:avLst/>
+          </a:prstGeom>
+          <a:noFill/>
+          <a:ln/>
+        </p:spPr>
+        <p:txBody>
+          <a:bodyPr wrap="square" lIns="0" tIns="0" rIns="0" bIns="0" rtlCol="0" anchor="ctr"/>
+          <a:lstStyle/>
+          <a:p>
+            <a:pPr indent="0" marL="0">
+              <a:buNone/>
+            </a:pPr>
+            <a:r>
+              <a:rPr lang="en-US" sz="900" spc="300" kern="0" dirty="0">
+                <a:solidFill>
+                  <a:srgbClr val="A8875A"/>
+                </a:solidFill>
+                <a:latin typeface="Arial" pitchFamily="34" charset="0"/>
+                <a:ea typeface="Arial" pitchFamily="34" charset="-122"/>
+                <a:cs typeface="Arial" pitchFamily="34" charset="-120"/>
+              </a:rPr>
+              <a:t>PIÙ URBANA</a:t>
+            </a:r>
+            <a:endParaRPr lang="en-US" sz="900" dirty="0"/>
+          </a:p>
+        </p:txBody>
+      </p:sp>
+      <p:sp>
+        <p:nvSpPr>
+          <p:cNvPr id="25" name="Text 23"/>
+          <p:cNvSpPr txBox="1"/>
+          <p:nvPr/>
+        </p:nvSpPr>
+        <p:spPr>
+          <a:xfrm>
+            <a:off x="9144000" y="3063240"/>
+            <a:ext cx="2103120" cy="1920240"/>
           </a:xfrm>
           <a:prstGeom prst="rect">
             <a:avLst/>
@@ -5894,7 +7538,7 @@
               <a:buNone/>
             </a:pPr>
             <a:r>
-              <a:rPr lang="en-US" sz="1250" dirty="0">
+              <a:rPr lang="en-US" sz="1200" dirty="0">
                 <a:solidFill>
                   <a:srgbClr val="5E6266"/>
                 </a:solidFill>
@@ -5902,21 +7546,260 @@
                 <a:ea typeface="Arial" pitchFamily="34" charset="-122"/>
                 <a:cs typeface="Arial" pitchFamily="34" charset="-120"/>
               </a:rPr>
-              <a:t>Riprese in strada da verificare con la Mission Cinéma della Ville de Paris. Metro con autorizzazione RATP. Giardini e interni con i gestori.</a:t>
-            </a:r>
-            <a:endParaRPr lang="en-US" sz="1250" dirty="0"/>
-          </a:p>
-        </p:txBody>
-      </p:sp>
-      <p:sp>
-        <p:nvSpPr>
-          <p:cNvPr id="13" name="Shape 11"/>
+              <a:t>Brera, Quadrilatero, tram storici, gallerie, nebbia. Logistica semplice per la troupe.</a:t>
+            </a:r>
+            <a:endParaRPr lang="en-US" sz="1200" dirty="0"/>
+          </a:p>
+        </p:txBody>
+      </p:sp>
+      <p:sp>
+        <p:nvSpPr>
+          <p:cNvPr id="26" name="Text 24"/>
+          <p:cNvSpPr txBox="1"/>
+          <p:nvPr/>
+        </p:nvSpPr>
+        <p:spPr>
+          <a:xfrm>
+            <a:off x="9144000" y="5029200"/>
+            <a:ext cx="2103120" cy="274320"/>
+          </a:xfrm>
+          <a:prstGeom prst="rect">
+            <a:avLst/>
+          </a:prstGeom>
+          <a:noFill/>
+          <a:ln/>
+        </p:spPr>
+        <p:txBody>
+          <a:bodyPr wrap="square" lIns="0" tIns="0" rIns="0" bIns="0" rtlCol="0" anchor="ctr"/>
+          <a:lstStyle/>
+          <a:p>
+            <a:pPr indent="0" marL="0">
+              <a:buNone/>
+            </a:pPr>
+            <a:r>
+              <a:rPr lang="en-US" sz="1000" spc="400" kern="0" dirty="0">
+                <a:solidFill>
+                  <a:srgbClr val="8A8D90"/>
+                </a:solidFill>
+                <a:latin typeface="Arial" pitchFamily="34" charset="0"/>
+                <a:ea typeface="Arial" pitchFamily="34" charset="-122"/>
+                <a:cs typeface="Arial" pitchFamily="34" charset="-120"/>
+              </a:rPr>
+              <a:t>CONTRO</a:t>
+            </a:r>
+            <a:endParaRPr lang="en-US" sz="1000" dirty="0"/>
+          </a:p>
+        </p:txBody>
+      </p:sp>
+      <p:sp>
+        <p:nvSpPr>
+          <p:cNvPr id="27" name="Text 25"/>
+          <p:cNvSpPr txBox="1"/>
+          <p:nvPr/>
+        </p:nvSpPr>
+        <p:spPr>
+          <a:xfrm>
+            <a:off x="9144000" y="5303520"/>
+            <a:ext cx="2103120" cy="640080"/>
+          </a:xfrm>
+          <a:prstGeom prst="rect">
+            <a:avLst/>
+          </a:prstGeom>
+          <a:noFill/>
+          <a:ln/>
+        </p:spPr>
+        <p:txBody>
+          <a:bodyPr wrap="square" lIns="0" tIns="0" rIns="0" bIns="0" rtlCol="0" anchor="t"/>
+          <a:lstStyle/>
+          <a:p>
+            <a:pPr indent="0" marL="0">
+              <a:lnSpc>
+                <a:spcPct val="115000"/>
+              </a:lnSpc>
+              <a:spcAft>
+                <a:spcPts val="600"/>
+              </a:spcAft>
+              <a:buNone/>
+            </a:pPr>
+            <a:r>
+              <a:rPr lang="en-US" sz="1150" dirty="0">
+                <a:solidFill>
+                  <a:srgbClr val="5E6266"/>
+                </a:solidFill>
+                <a:latin typeface="Arial" pitchFamily="34" charset="0"/>
+                <a:ea typeface="Arial" pitchFamily="34" charset="-122"/>
+                <a:cs typeface="Arial" pitchFamily="34" charset="-120"/>
+              </a:rPr>
+              <a:t>Meno romantica e molto riconoscibile.</a:t>
+            </a:r>
+            <a:endParaRPr lang="en-US" sz="1150" dirty="0"/>
+          </a:p>
+        </p:txBody>
+      </p:sp>
+      <p:sp>
+        <p:nvSpPr>
+          <p:cNvPr id="28" name="Text 26"/>
+          <p:cNvSpPr txBox="1"/>
+          <p:nvPr/>
+        </p:nvSpPr>
+        <p:spPr>
+          <a:xfrm>
+            <a:off x="685800" y="6263640"/>
+            <a:ext cx="10058400" cy="274320"/>
+          </a:xfrm>
+          <a:prstGeom prst="rect">
+            <a:avLst/>
+          </a:prstGeom>
+          <a:noFill/>
+          <a:ln/>
+        </p:spPr>
+        <p:txBody>
+          <a:bodyPr wrap="square" lIns="0" tIns="0" rIns="0" bIns="0" rtlCol="0" anchor="t"/>
+          <a:lstStyle/>
+          <a:p>
+            <a:pPr indent="0" marL="0">
+              <a:lnSpc>
+                <a:spcPct val="115000"/>
+              </a:lnSpc>
+              <a:spcAft>
+                <a:spcPts val="600"/>
+              </a:spcAft>
+              <a:buNone/>
+            </a:pPr>
+            <a:r>
+              <a:rPr lang="en-US" sz="1000" dirty="0">
+                <a:solidFill>
+                  <a:srgbClr val="8A8D90"/>
+                </a:solidFill>
+                <a:latin typeface="Arial" pitchFamily="34" charset="0"/>
+                <a:ea typeface="Arial" pitchFamily="34" charset="-122"/>
+                <a:cs typeface="Arial" pitchFamily="34" charset="-120"/>
+              </a:rPr>
+              <a:t>Valutazione qualitativa: costi e permessi da confrontare con preventivi reali.</a:t>
+            </a:r>
+            <a:endParaRPr lang="en-US" sz="1000" dirty="0"/>
+          </a:p>
+        </p:txBody>
+      </p:sp>
+    </p:spTree>
+  </p:cSld>
+  <p:clrMapOvr>
+    <a:masterClrMapping/>
+  </p:clrMapOvr>
+</p:sld>
+</file>
+
+<file path=ppt/slides/slide16.xml><?xml version="1.0" encoding="utf-8"?>
+<p:sld xmlns:a="http://schemas.openxmlformats.org/drawingml/2006/main" xmlns:r="http://schemas.openxmlformats.org/officeDocument/2006/relationships" xmlns:p="http://schemas.openxmlformats.org/presentationml/2006/main">
+  <p:cSld name="Slide 16">
+    <p:bg>
+      <p:bgPr>
+        <a:solidFill>
+          <a:srgbClr val="F2F2F0"/>
+        </a:solidFill>
+      </p:bgPr>
+    </p:bg>
+    <p:spTree>
+      <p:nvGrpSpPr>
+        <p:cNvPr id="1" name=""/>
+        <p:cNvGrpSpPr/>
+        <p:nvPr/>
+      </p:nvGrpSpPr>
+      <p:grpSpPr>
+        <a:xfrm>
+          <a:off x="0" y="0"/>
+          <a:ext cx="0" cy="0"/>
+          <a:chOff x="0" y="0"/>
+          <a:chExt cx="0" cy="0"/>
+        </a:xfrm>
+      </p:grpSpPr>
+      <p:sp>
+        <p:nvSpPr>
+          <p:cNvPr id="2" name="Text 0"/>
+          <p:cNvSpPr txBox="1"/>
+          <p:nvPr/>
+        </p:nvSpPr>
+        <p:spPr>
+          <a:xfrm>
+            <a:off x="685800" y="548640"/>
+            <a:ext cx="5486400" cy="274320"/>
+          </a:xfrm>
+          <a:prstGeom prst="rect">
+            <a:avLst/>
+          </a:prstGeom>
+          <a:noFill/>
+          <a:ln/>
+        </p:spPr>
+        <p:txBody>
+          <a:bodyPr wrap="square" lIns="0" tIns="0" rIns="0" bIns="0" rtlCol="0" anchor="ctr"/>
+          <a:lstStyle/>
+          <a:p>
+            <a:pPr indent="0" marL="0">
+              <a:buNone/>
+            </a:pPr>
+            <a:r>
+              <a:rPr lang="en-US" sz="1000" spc="400" kern="0" dirty="0">
+                <a:solidFill>
+                  <a:srgbClr val="5E6266"/>
+                </a:solidFill>
+                <a:latin typeface="Arial" pitchFamily="34" charset="0"/>
+                <a:ea typeface="Arial" pitchFamily="34" charset="-122"/>
+                <a:cs typeface="Arial" pitchFamily="34" charset="-120"/>
+              </a:rPr>
+              <a:t>09 — PRODUZIONE</a:t>
+            </a:r>
+            <a:endParaRPr lang="en-US" sz="1000" dirty="0"/>
+          </a:p>
+        </p:txBody>
+      </p:sp>
+      <p:sp>
+        <p:nvSpPr>
+          <p:cNvPr id="3" name="Text 1"/>
+          <p:cNvSpPr txBox="1"/>
+          <p:nvPr/>
+        </p:nvSpPr>
+        <p:spPr>
+          <a:xfrm>
+            <a:off x="685800" y="868680"/>
+            <a:ext cx="7315200" cy="731520"/>
+          </a:xfrm>
+          <a:prstGeom prst="rect">
+            <a:avLst/>
+          </a:prstGeom>
+          <a:noFill/>
+          <a:ln/>
+        </p:spPr>
+        <p:txBody>
+          <a:bodyPr wrap="square" lIns="0" tIns="0" rIns="0" bIns="0" rtlCol="0" anchor="t"/>
+          <a:lstStyle/>
+          <a:p>
+            <a:pPr indent="0" marL="0">
+              <a:buNone/>
+            </a:pPr>
+            <a:r>
+              <a:rPr lang="en-US" sz="3400" dirty="0">
+                <a:solidFill>
+                  <a:srgbClr val="1E2023"/>
+                </a:solidFill>
+                <a:latin typeface="Cambria" pitchFamily="34" charset="0"/>
+                <a:ea typeface="Cambria" pitchFamily="34" charset="-122"/>
+                <a:cs typeface="Cambria" pitchFamily="34" charset="-120"/>
+              </a:rPr>
+              <a:t>Come la realizziamo</a:t>
+            </a:r>
+            <a:endParaRPr lang="en-US" sz="3400" dirty="0"/>
+          </a:p>
+        </p:txBody>
+      </p:sp>
+      <p:sp>
+        <p:nvSpPr>
+          <p:cNvPr id="4" name="Shape 2"/>
           <p:cNvSpPr/>
           <p:nvPr/>
         </p:nvSpPr>
         <p:spPr>
           <a:xfrm>
-            <a:off x="6217920" y="3794760"/>
+            <a:off x="685800" y="1783080"/>
             <a:ext cx="5257800" cy="1783080"/>
           </a:xfrm>
           <a:prstGeom prst="rect">
@@ -5935,13 +7818,13 @@
       </p:sp>
       <p:sp>
         <p:nvSpPr>
-          <p:cNvPr id="14" name="Text 12"/>
-          <p:cNvSpPr txBox="1"/>
-          <p:nvPr/>
-        </p:nvSpPr>
-        <p:spPr>
-          <a:xfrm>
-            <a:off x="6492240" y="4023360"/>
+          <p:cNvPr id="5" name="Text 3"/>
+          <p:cNvSpPr txBox="1"/>
+          <p:nvPr/>
+        </p:nvSpPr>
+        <p:spPr>
+          <a:xfrm>
+            <a:off x="960120" y="2011680"/>
             <a:ext cx="4709160" cy="365760"/>
           </a:xfrm>
           <a:prstGeom prst="rect">
@@ -5966,7 +7849,7 @@
                 <a:ea typeface="Cambria" pitchFamily="34" charset="-122"/>
                 <a:cs typeface="Cambria" pitchFamily="34" charset="-120"/>
               </a:rPr>
-              <a:t>Meteo e cappelli</a:t>
+              <a:t>Quando</a:t>
             </a:r>
             <a:endParaRPr lang="en-US" sz="1800" dirty="0"/>
           </a:p>
@@ -5974,13 +7857,13 @@
       </p:sp>
       <p:sp>
         <p:nvSpPr>
-          <p:cNvPr id="15" name="Text 13"/>
-          <p:cNvSpPr txBox="1"/>
-          <p:nvPr/>
-        </p:nvSpPr>
-        <p:spPr>
-          <a:xfrm>
-            <a:off x="6492240" y="4480560"/>
+          <p:cNvPr id="6" name="Text 4"/>
+          <p:cNvSpPr txBox="1"/>
+          <p:nvPr/>
+        </p:nvSpPr>
+        <p:spPr>
+          <a:xfrm>
+            <a:off x="960120" y="2468880"/>
             <a:ext cx="4709160" cy="1005840"/>
           </a:xfrm>
           <a:prstGeom prst="rect">
@@ -6011,7 +7894,7 @@
                 <a:ea typeface="Arial" pitchFamily="34" charset="-122"/>
                 <a:cs typeface="Arial" pitchFamily="34" charset="-120"/>
               </a:rPr>
-              <a:t>Pioggia vera quando c’è, artificiale se serve. Piano B al coperto (caffè, ascensore, portici). Trattamento idrorepellente e doppioni dei cappelli in feltro.</a:t>
+              <a:t>Da metà novembre a inizio dicembre: foglie ancora a terra, luce bassa, pioggia e nebbia al mattino. 2 giorni di scatto più 1 di riserva meteo.</a:t>
             </a:r>
             <a:endParaRPr lang="en-US" sz="1250" dirty="0"/>
           </a:p>
@@ -6019,14 +7902,39 @@
       </p:sp>
       <p:sp>
         <p:nvSpPr>
-          <p:cNvPr id="16" name="Text 14"/>
-          <p:cNvSpPr txBox="1"/>
-          <p:nvPr/>
-        </p:nvSpPr>
-        <p:spPr>
-          <a:xfrm>
-            <a:off x="685800" y="5852160"/>
-            <a:ext cx="1828800" cy="274320"/>
+          <p:cNvPr id="7" name="Shape 5"/>
+          <p:cNvSpPr/>
+          <p:nvPr/>
+        </p:nvSpPr>
+        <p:spPr>
+          <a:xfrm>
+            <a:off x="6217920" y="1783080"/>
+            <a:ext cx="5257800" cy="1783080"/>
+          </a:xfrm>
+          <a:prstGeom prst="rect">
+            <a:avLst/>
+          </a:prstGeom>
+          <a:solidFill>
+            <a:srgbClr val="FFFFFF"/>
+          </a:solidFill>
+          <a:ln w="9525">
+            <a:solidFill>
+              <a:srgbClr val="DCDDDC"/>
+            </a:solidFill>
+            <a:prstDash val="solid"/>
+          </a:ln>
+        </p:spPr>
+      </p:sp>
+      <p:sp>
+        <p:nvSpPr>
+          <p:cNvPr id="8" name="Text 6"/>
+          <p:cNvSpPr txBox="1"/>
+          <p:nvPr/>
+        </p:nvSpPr>
+        <p:spPr>
+          <a:xfrm>
+            <a:off x="6492240" y="2011680"/>
+            <a:ext cx="4709160" cy="365760"/>
           </a:xfrm>
           <a:prstGeom prst="rect">
             <a:avLst/>
@@ -6042,30 +7950,30 @@
               <a:buNone/>
             </a:pPr>
             <a:r>
-              <a:rPr lang="en-US" sz="1000" spc="400" kern="0" dirty="0">
-                <a:solidFill>
-                  <a:srgbClr val="A8875A"/>
-                </a:solidFill>
-                <a:latin typeface="Arial" pitchFamily="34" charset="0"/>
-                <a:ea typeface="Arial" pitchFamily="34" charset="-122"/>
-                <a:cs typeface="Arial" pitchFamily="34" charset="-120"/>
-              </a:rPr>
-              <a:t>CONSEGNE</a:t>
-            </a:r>
-            <a:endParaRPr lang="en-US" sz="1000" dirty="0"/>
-          </a:p>
-        </p:txBody>
-      </p:sp>
-      <p:sp>
-        <p:nvSpPr>
-          <p:cNvPr id="17" name="Text 15"/>
-          <p:cNvSpPr txBox="1"/>
-          <p:nvPr/>
-        </p:nvSpPr>
-        <p:spPr>
-          <a:xfrm>
-            <a:off x="1920240" y="5788152"/>
-            <a:ext cx="9601200" cy="365760"/>
+              <a:rPr lang="en-US" sz="1800" i="1" dirty="0">
+                <a:solidFill>
+                  <a:srgbClr val="1E2023"/>
+                </a:solidFill>
+                <a:latin typeface="Cambria" pitchFamily="34" charset="0"/>
+                <a:ea typeface="Cambria" pitchFamily="34" charset="-122"/>
+                <a:cs typeface="Cambria" pitchFamily="34" charset="-120"/>
+              </a:rPr>
+              <a:t>Troupe leggera</a:t>
+            </a:r>
+            <a:endParaRPr lang="en-US" sz="1800" dirty="0"/>
+          </a:p>
+        </p:txBody>
+      </p:sp>
+      <p:sp>
+        <p:nvSpPr>
+          <p:cNvPr id="9" name="Text 7"/>
+          <p:cNvSpPr txBox="1"/>
+          <p:nvPr/>
+        </p:nvSpPr>
+        <p:spPr>
+          <a:xfrm>
+            <a:off x="6492240" y="2468880"/>
+            <a:ext cx="4709160" cy="1005840"/>
           </a:xfrm>
           <a:prstGeom prst="rect">
             <a:avLst/>
@@ -6087,6 +7995,308 @@
               <a:buNone/>
             </a:pPr>
             <a:r>
+              <a:rPr lang="en-US" sz="1250" dirty="0">
+                <a:solidFill>
+                  <a:srgbClr val="5E6266"/>
+                </a:solidFill>
+                <a:latin typeface="Arial" pitchFamily="34" charset="0"/>
+                <a:ea typeface="Arial" pitchFamily="34" charset="-122"/>
+                <a:cs typeface="Arial" pitchFamily="34" charset="-120"/>
+              </a:rPr>
+              <a:t>Fotografo con teleobiettivo, videomaker, stylist, hair &amp; make-up, producer locale. Una modella, qualche comparsa per strada e in metro.</a:t>
+            </a:r>
+            <a:endParaRPr lang="en-US" sz="1250" dirty="0"/>
+          </a:p>
+        </p:txBody>
+      </p:sp>
+      <p:sp>
+        <p:nvSpPr>
+          <p:cNvPr id="10" name="Shape 8"/>
+          <p:cNvSpPr/>
+          <p:nvPr/>
+        </p:nvSpPr>
+        <p:spPr>
+          <a:xfrm>
+            <a:off x="685800" y="3794760"/>
+            <a:ext cx="5257800" cy="1783080"/>
+          </a:xfrm>
+          <a:prstGeom prst="rect">
+            <a:avLst/>
+          </a:prstGeom>
+          <a:solidFill>
+            <a:srgbClr val="FFFFFF"/>
+          </a:solidFill>
+          <a:ln w="9525">
+            <a:solidFill>
+              <a:srgbClr val="DCDDDC"/>
+            </a:solidFill>
+            <a:prstDash val="solid"/>
+          </a:ln>
+        </p:spPr>
+      </p:sp>
+      <p:sp>
+        <p:nvSpPr>
+          <p:cNvPr id="11" name="Text 9"/>
+          <p:cNvSpPr txBox="1"/>
+          <p:nvPr/>
+        </p:nvSpPr>
+        <p:spPr>
+          <a:xfrm>
+            <a:off x="960120" y="4023360"/>
+            <a:ext cx="4709160" cy="365760"/>
+          </a:xfrm>
+          <a:prstGeom prst="rect">
+            <a:avLst/>
+          </a:prstGeom>
+          <a:noFill/>
+          <a:ln/>
+        </p:spPr>
+        <p:txBody>
+          <a:bodyPr wrap="square" lIns="0" tIns="0" rIns="0" bIns="0" rtlCol="0" anchor="ctr"/>
+          <a:lstStyle/>
+          <a:p>
+            <a:pPr indent="0" marL="0">
+              <a:buNone/>
+            </a:pPr>
+            <a:r>
+              <a:rPr lang="en-US" sz="1800" i="1" dirty="0">
+                <a:solidFill>
+                  <a:srgbClr val="1E2023"/>
+                </a:solidFill>
+                <a:latin typeface="Cambria" pitchFamily="34" charset="0"/>
+                <a:ea typeface="Cambria" pitchFamily="34" charset="-122"/>
+                <a:cs typeface="Cambria" pitchFamily="34" charset="-120"/>
+              </a:rPr>
+              <a:t>Permessi</a:t>
+            </a:r>
+            <a:endParaRPr lang="en-US" sz="1800" dirty="0"/>
+          </a:p>
+        </p:txBody>
+      </p:sp>
+      <p:sp>
+        <p:nvSpPr>
+          <p:cNvPr id="12" name="Text 10"/>
+          <p:cNvSpPr txBox="1"/>
+          <p:nvPr/>
+        </p:nvSpPr>
+        <p:spPr>
+          <a:xfrm>
+            <a:off x="960120" y="4480560"/>
+            <a:ext cx="4709160" cy="1005840"/>
+          </a:xfrm>
+          <a:prstGeom prst="rect">
+            <a:avLst/>
+          </a:prstGeom>
+          <a:noFill/>
+          <a:ln/>
+        </p:spPr>
+        <p:txBody>
+          <a:bodyPr wrap="square" lIns="0" tIns="0" rIns="0" bIns="0" rtlCol="0" anchor="t"/>
+          <a:lstStyle/>
+          <a:p>
+            <a:pPr indent="0" marL="0">
+              <a:lnSpc>
+                <a:spcPct val="115000"/>
+              </a:lnSpc>
+              <a:spcAft>
+                <a:spcPts val="600"/>
+              </a:spcAft>
+              <a:buNone/>
+            </a:pPr>
+            <a:r>
+              <a:rPr lang="en-US" sz="1250" dirty="0">
+                <a:solidFill>
+                  <a:srgbClr val="5E6266"/>
+                </a:solidFill>
+                <a:latin typeface="Arial" pitchFamily="34" charset="0"/>
+                <a:ea typeface="Arial" pitchFamily="34" charset="-122"/>
+                <a:cs typeface="Arial" pitchFamily="34" charset="-120"/>
+              </a:rPr>
+              <a:t>Riprese in strada da verificare con la Mission Cinéma della Ville de Paris. Metro con autorizzazione RATP. Giardini e interni con i gestori.</a:t>
+            </a:r>
+            <a:endParaRPr lang="en-US" sz="1250" dirty="0"/>
+          </a:p>
+        </p:txBody>
+      </p:sp>
+      <p:sp>
+        <p:nvSpPr>
+          <p:cNvPr id="13" name="Shape 11"/>
+          <p:cNvSpPr/>
+          <p:nvPr/>
+        </p:nvSpPr>
+        <p:spPr>
+          <a:xfrm>
+            <a:off x="6217920" y="3794760"/>
+            <a:ext cx="5257800" cy="1783080"/>
+          </a:xfrm>
+          <a:prstGeom prst="rect">
+            <a:avLst/>
+          </a:prstGeom>
+          <a:solidFill>
+            <a:srgbClr val="FFFFFF"/>
+          </a:solidFill>
+          <a:ln w="9525">
+            <a:solidFill>
+              <a:srgbClr val="DCDDDC"/>
+            </a:solidFill>
+            <a:prstDash val="solid"/>
+          </a:ln>
+        </p:spPr>
+      </p:sp>
+      <p:sp>
+        <p:nvSpPr>
+          <p:cNvPr id="14" name="Text 12"/>
+          <p:cNvSpPr txBox="1"/>
+          <p:nvPr/>
+        </p:nvSpPr>
+        <p:spPr>
+          <a:xfrm>
+            <a:off x="6492240" y="4023360"/>
+            <a:ext cx="4709160" cy="365760"/>
+          </a:xfrm>
+          <a:prstGeom prst="rect">
+            <a:avLst/>
+          </a:prstGeom>
+          <a:noFill/>
+          <a:ln/>
+        </p:spPr>
+        <p:txBody>
+          <a:bodyPr wrap="square" lIns="0" tIns="0" rIns="0" bIns="0" rtlCol="0" anchor="ctr"/>
+          <a:lstStyle/>
+          <a:p>
+            <a:pPr indent="0" marL="0">
+              <a:buNone/>
+            </a:pPr>
+            <a:r>
+              <a:rPr lang="en-US" sz="1800" i="1" dirty="0">
+                <a:solidFill>
+                  <a:srgbClr val="1E2023"/>
+                </a:solidFill>
+                <a:latin typeface="Cambria" pitchFamily="34" charset="0"/>
+                <a:ea typeface="Cambria" pitchFamily="34" charset="-122"/>
+                <a:cs typeface="Cambria" pitchFamily="34" charset="-120"/>
+              </a:rPr>
+              <a:t>Meteo e cappelli</a:t>
+            </a:r>
+            <a:endParaRPr lang="en-US" sz="1800" dirty="0"/>
+          </a:p>
+        </p:txBody>
+      </p:sp>
+      <p:sp>
+        <p:nvSpPr>
+          <p:cNvPr id="15" name="Text 13"/>
+          <p:cNvSpPr txBox="1"/>
+          <p:nvPr/>
+        </p:nvSpPr>
+        <p:spPr>
+          <a:xfrm>
+            <a:off x="6492240" y="4480560"/>
+            <a:ext cx="4709160" cy="1005840"/>
+          </a:xfrm>
+          <a:prstGeom prst="rect">
+            <a:avLst/>
+          </a:prstGeom>
+          <a:noFill/>
+          <a:ln/>
+        </p:spPr>
+        <p:txBody>
+          <a:bodyPr wrap="square" lIns="0" tIns="0" rIns="0" bIns="0" rtlCol="0" anchor="t"/>
+          <a:lstStyle/>
+          <a:p>
+            <a:pPr indent="0" marL="0">
+              <a:lnSpc>
+                <a:spcPct val="115000"/>
+              </a:lnSpc>
+              <a:spcAft>
+                <a:spcPts val="600"/>
+              </a:spcAft>
+              <a:buNone/>
+            </a:pPr>
+            <a:r>
+              <a:rPr lang="en-US" sz="1250" dirty="0">
+                <a:solidFill>
+                  <a:srgbClr val="5E6266"/>
+                </a:solidFill>
+                <a:latin typeface="Arial" pitchFamily="34" charset="0"/>
+                <a:ea typeface="Arial" pitchFamily="34" charset="-122"/>
+                <a:cs typeface="Arial" pitchFamily="34" charset="-120"/>
+              </a:rPr>
+              <a:t>Pioggia vera quando c’è, artificiale se serve. Piano B al coperto (caffè, ascensore, portici). Trattamento idrorepellente e doppioni dei cappelli in feltro.</a:t>
+            </a:r>
+            <a:endParaRPr lang="en-US" sz="1250" dirty="0"/>
+          </a:p>
+        </p:txBody>
+      </p:sp>
+      <p:sp>
+        <p:nvSpPr>
+          <p:cNvPr id="16" name="Text 14"/>
+          <p:cNvSpPr txBox="1"/>
+          <p:nvPr/>
+        </p:nvSpPr>
+        <p:spPr>
+          <a:xfrm>
+            <a:off x="685800" y="5852160"/>
+            <a:ext cx="1828800" cy="274320"/>
+          </a:xfrm>
+          <a:prstGeom prst="rect">
+            <a:avLst/>
+          </a:prstGeom>
+          <a:noFill/>
+          <a:ln/>
+        </p:spPr>
+        <p:txBody>
+          <a:bodyPr wrap="square" lIns="0" tIns="0" rIns="0" bIns="0" rtlCol="0" anchor="ctr"/>
+          <a:lstStyle/>
+          <a:p>
+            <a:pPr indent="0" marL="0">
+              <a:buNone/>
+            </a:pPr>
+            <a:r>
+              <a:rPr lang="en-US" sz="1000" spc="400" kern="0" dirty="0">
+                <a:solidFill>
+                  <a:srgbClr val="A8875A"/>
+                </a:solidFill>
+                <a:latin typeface="Arial" pitchFamily="34" charset="0"/>
+                <a:ea typeface="Arial" pitchFamily="34" charset="-122"/>
+                <a:cs typeface="Arial" pitchFamily="34" charset="-120"/>
+              </a:rPr>
+              <a:t>CONSEGNE</a:t>
+            </a:r>
+            <a:endParaRPr lang="en-US" sz="1000" dirty="0"/>
+          </a:p>
+        </p:txBody>
+      </p:sp>
+      <p:sp>
+        <p:nvSpPr>
+          <p:cNvPr id="17" name="Text 15"/>
+          <p:cNvSpPr txBox="1"/>
+          <p:nvPr/>
+        </p:nvSpPr>
+        <p:spPr>
+          <a:xfrm>
+            <a:off x="1920240" y="5788152"/>
+            <a:ext cx="9601200" cy="365760"/>
+          </a:xfrm>
+          <a:prstGeom prst="rect">
+            <a:avLst/>
+          </a:prstGeom>
+          <a:noFill/>
+          <a:ln/>
+        </p:spPr>
+        <p:txBody>
+          <a:bodyPr wrap="square" lIns="0" tIns="0" rIns="0" bIns="0" rtlCol="0" anchor="t"/>
+          <a:lstStyle/>
+          <a:p>
+            <a:pPr indent="0" marL="0">
+              <a:lnSpc>
+                <a:spcPct val="115000"/>
+              </a:lnSpc>
+              <a:spcAft>
+                <a:spcPts val="600"/>
+              </a:spcAft>
+              <a:buNone/>
+            </a:pPr>
+            <a:r>
               <a:rPr lang="en-US" sz="1300" dirty="0">
                 <a:solidFill>
                   <a:srgbClr val="1E2023"/>
@@ -6134,7 +8344,7 @@
                 <a:ea typeface="Arial" pitchFamily="34" charset="-122"/>
                 <a:cs typeface="Arial" pitchFamily="34" charset="-120"/>
               </a:rPr>
-              <a:t>14</a:t>
+              <a:t>16</a:t>
             </a:r>
             <a:endParaRPr lang="en-US" sz="900" dirty="0"/>
           </a:p>
@@ -6148,9 +8358,9 @@
 </p:sld>
 </file>
 
-<file path=ppt/slides/slide15.xml><?xml version="1.0" encoding="utf-8"?>
+<file path=ppt/slides/slide17.xml><?xml version="1.0" encoding="utf-8"?>
 <p:sld xmlns:a="http://schemas.openxmlformats.org/drawingml/2006/main" xmlns:r="http://schemas.openxmlformats.org/officeDocument/2006/relationships" xmlns:p="http://schemas.openxmlformats.org/presentationml/2006/main">
-  <p:cSld name="Slide 15">
+  <p:cSld name="Slide 17">
     <p:bg>
       <p:bgPr>
         <a:solidFill>

</xml_diff>